<commit_message>
create a small UI
</commit_message>
<xml_diff>
--- a/presentations/GP8001_GE2_AI_Application_Results.pptx
+++ b/presentations/GP8001_GE2_AI_Application_Results.pptx
@@ -1029,7 +1029,99 @@
                 <a:ea typeface="Times New Roman"/>
                 <a:cs typeface="Times New Roman"/>
               </a:rPr>
-              <a:t>We extended the original MLP experiment to three more complex neural network families. The original model has two hidden layers with 64 and 32 neurons and 9,014 parameters. The deeper MLPs have three or five hidden layers, with up to 512 neurons in the first layer. Residual networks add skip connections, which help information and gradients pass through deeper networks. The Transformer represents each original field as a token and uses attention to combine information across fields. It also has a classification token. The largest tested network has more than 821,000 parameters. Logistic regression remains our main reference, alongside the earlier random forest, extra trees and gradient boosting experiments.</a:t>
+              <a:t>We compared three traditional machine learning models. Logistic regression learns a weight for each encoded feature and converts the resulting scores into probabilities for the 22 careers. We use TF-IDF features and regularisation C equal to 16. This is the model currently used by our CSV prototype.</a:t>
+            </a:r>
+            <a:endParaRPr lang="en-SG" sz="1200"/>
+          </a:p>
+          <a:p>
+            <a:pPr algn="l">
+              <a:lnSpc>
+                <a:spcPct val="105000"/>
+              </a:lnSpc>
+              <a:spcAft>
+                <a:spcPts val="0"/>
+              </a:spcAft>
+              <a:buNone/>
+            </a:pPr>
+            <a:r>
+              <a:rPr lang="en-SG" sz="1200" b="0">
+                <a:solidFill>
+                  <a:srgbClr val="000000"/>
+                </a:solidFill>
+                <a:latin typeface="Times New Roman"/>
+                <a:ea typeface="Times New Roman"/>
+                <a:cs typeface="Times New Roman"/>
+              </a:rPr>
+              <a:t/>
+            </a:r>
+            <a:endParaRPr lang="en-SG" sz="1200"/>
+          </a:p>
+          <a:p>
+            <a:pPr algn="l">
+              <a:lnSpc>
+                <a:spcPct val="105000"/>
+              </a:lnSpc>
+              <a:spcAft>
+                <a:spcPts val="0"/>
+              </a:spcAft>
+              <a:buNone/>
+            </a:pPr>
+            <a:r>
+              <a:rPr lang="en-SG" sz="1200" b="0">
+                <a:solidFill>
+                  <a:srgbClr val="000000"/>
+                </a:solidFill>
+                <a:latin typeface="Times New Roman"/>
+                <a:ea typeface="Times New Roman"/>
+                <a:cs typeface="Times New Roman"/>
+              </a:rPr>
+              <a:t>Random Forest averages predictions from 500 decision trees. Different trees use different training samples and feature choices, allowing the ensemble to capture nonlinear patterns. Extra Trees also uses 500 trees, with additional randomness in the split thresholds. Both tree models use binary feature presence and require at least two training profiles in each leaf.</a:t>
+            </a:r>
+            <a:endParaRPr lang="en-SG" sz="1200"/>
+          </a:p>
+          <a:p>
+            <a:pPr algn="l">
+              <a:lnSpc>
+                <a:spcPct val="105000"/>
+              </a:lnSpc>
+              <a:spcAft>
+                <a:spcPts val="0"/>
+              </a:spcAft>
+              <a:buNone/>
+            </a:pPr>
+            <a:r>
+              <a:rPr lang="en-SG" sz="1200" b="0">
+                <a:solidFill>
+                  <a:srgbClr val="000000"/>
+                </a:solidFill>
+                <a:latin typeface="Times New Roman"/>
+                <a:ea typeface="Times New Roman"/>
+                <a:cs typeface="Times New Roman"/>
+              </a:rPr>
+              <a:t/>
+            </a:r>
+            <a:endParaRPr lang="en-SG" sz="1200"/>
+          </a:p>
+          <a:p>
+            <a:pPr algn="l">
+              <a:lnSpc>
+                <a:spcPct val="105000"/>
+              </a:lnSpc>
+              <a:spcAft>
+                <a:spcPts val="0"/>
+              </a:spcAft>
+              <a:buNone/>
+            </a:pPr>
+            <a:r>
+              <a:rPr lang="en-SG" sz="1200" b="0">
+                <a:solidFill>
+                  <a:srgbClr val="000000"/>
+                </a:solidFill>
+                <a:latin typeface="Times New Roman"/>
+                <a:ea typeface="Times New Roman"/>
+                <a:cs typeface="Times New Roman"/>
+              </a:rPr>
+              <a:t>All models are evaluated using the same five stratified folds, with 12,000 training profiles and 3,000 test profiles per fold. Preprocessing is fitted on the training data for each fold.</a:t>
             </a:r>
             <a:endParaRPr lang="en-SG" sz="1200"/>
           </a:p>
@@ -1162,7 +1254,7 @@
                 <a:ea typeface="Times New Roman"/>
                 <a:cs typeface="Times New Roman"/>
               </a:rPr>
-              <a:t>We tested 18 configurations in each of five folds, giving 90 tuning trials. These vary the learning rate, network size, dropout, weight decay, batch size and input encoding. The new networks use AdamW. Some keep the learning rate constant, while others reduce it when validation loss stalls or use cosine decay.</a:t>
+              <a:t>We also tested more complex deep learning approaches. The deep MLP passes encoded features through three or five hidden layers to learn nonlinear combinations. It uses GELU activations, LayerNorm and dropout, with about 68,000 to 227,000 trainable parameters across the tested settings.</a:t>
             </a:r>
             <a:endParaRPr lang="en-SG" sz="1200"/>
           </a:p>
@@ -1208,7 +1300,53 @@
                 <a:ea typeface="Times New Roman"/>
                 <a:cs typeface="Times New Roman"/>
               </a:rPr>
-              <a:t>Within each fold, 9,600 profiles train the candidates and 2,400 select their settings and stopping epoch. Preprocessing learns only from those inner training profiles. We then refit preprocessing and the selected network using all 12,000 training profiles, replaying the selected learning-rate schedule. The separate 3,000 test profiles do not influence tuning. Early stopping uses a patience of 12 epochs and a limit of 60. All trials stopped after 13 to 46 epochs. These are tested configurations, rather than an exhaustive search.</a:t>
+              <a:t>The field Transformer represents each of the 18 original fields as a token, adds a classification token, and uses attention to combine information across fields. It uses four attention heads and two or four blocks, with about 30,000 to 109,000 parameters. It is trained from scratch.</a:t>
+            </a:r>
+            <a:endParaRPr lang="en-SG" sz="1200"/>
+          </a:p>
+          <a:p>
+            <a:pPr algn="l">
+              <a:lnSpc>
+                <a:spcPct val="105000"/>
+              </a:lnSpc>
+              <a:spcAft>
+                <a:spcPts val="0"/>
+              </a:spcAft>
+              <a:buNone/>
+            </a:pPr>
+            <a:r>
+              <a:rPr lang="en-SG" sz="1200" b="0">
+                <a:solidFill>
+                  <a:srgbClr val="000000"/>
+                </a:solidFill>
+                <a:latin typeface="Times New Roman"/>
+                <a:ea typeface="Times New Roman"/>
+                <a:cs typeface="Times New Roman"/>
+              </a:rPr>
+              <a:t/>
+            </a:r>
+            <a:endParaRPr lang="en-SG" sz="1200"/>
+          </a:p>
+          <a:p>
+            <a:pPr algn="l">
+              <a:lnSpc>
+                <a:spcPct val="105000"/>
+              </a:lnSpc>
+              <a:spcAft>
+                <a:spcPts val="0"/>
+              </a:spcAft>
+              <a:buNone/>
+            </a:pPr>
+            <a:r>
+              <a:rPr lang="en-SG" sz="1200" b="0">
+                <a:solidFill>
+                  <a:srgbClr val="000000"/>
+                </a:solidFill>
+                <a:latin typeface="Times New Roman"/>
+                <a:ea typeface="Times New Roman"/>
+                <a:cs typeface="Times New Roman"/>
+              </a:rPr>
+              <a:t>The wider experiment tested 18 configurations across these two families and a residual network, giving 90 trials over five folds. AdamW learning rates were 0.0003, 0.001 and 0.003. We varied dropout, weight decay, batch size and learning-rate schedules. Early stopping used patience 12 and a maximum of 60 epochs. Within each training fold, 9,600 profiles trained candidates and 2,400 selected settings and stopping epochs. The selected network was then refitted on all 12,000 training profiles before evaluation on the separate 3,000 test profiles. The next slide compares the deep MLP and Transformer with our three traditional models.</a:t>
             </a:r>
             <a:endParaRPr lang="en-SG" sz="1200"/>
           </a:p>
@@ -7659,7 +7797,7 @@
                 <a:latin typeface="Times New Roman" panose="02020603050405020304" pitchFamily="18" charset="0"/>
                 <a:cs typeface="Times New Roman" panose="02020603050405020304" pitchFamily="18" charset="0"/>
               </a:rPr>
-              <a:t>Deep learning models</a:t>
+              <a:t>Machine learning models</a:t>
             </a:r>
           </a:p>
         </p:txBody>
@@ -7672,17 +7810,17 @@
         </p:nvGraphicFramePr>
         <p:xfrm>
           <a:off x="594360" y="1463040"/>
-          <a:ext cx="7406640" cy="2926080"/>
+          <a:ext cx="7406640" cy="2752344"/>
         </p:xfrm>
         <a:graphic>
           <a:graphicData uri="http://schemas.openxmlformats.org/drawingml/2006/table">
             <a:tbl>
               <a:tblPr firstRow="1" bandRow="0"/>
               <a:tblGrid>
-                <a:gridCol w="2148840"/>
-                <a:gridCol w="5257800"/>
+                <a:gridCol w="2331720"/>
+                <a:gridCol w="5074920"/>
               </a:tblGrid>
-              <a:tr h="365760">
+              <a:tr h="393192">
                 <a:tc>
                   <a:txBody>
                     <a:bodyPr wrap="square"/>
@@ -7706,7 +7844,7 @@
                           <a:ea typeface="Times New Roman"/>
                           <a:cs typeface="Times New Roman"/>
                         </a:rPr>
-                        <a:t>Network</a:t>
+                        <a:t>Model</a:t>
                       </a:r>
                       <a:endParaRPr lang="en-SG" sz="1700"/>
                     </a:p>
@@ -7754,7 +7892,7 @@
                           <a:ea typeface="Times New Roman"/>
                           <a:cs typeface="Times New Roman"/>
                         </a:rPr>
-                        <a:t>Architecture tested</a:t>
+                        <a:t>How it works and settings used</a:t>
                       </a:r>
                       <a:endParaRPr lang="en-SG" sz="1700"/>
                     </a:p>
@@ -7780,7 +7918,7 @@
                   </a:tcPr>
                 </a:tc>
               </a:tr>
-              <a:tr h="640080">
+              <a:tr h="786384">
                 <a:tc>
                   <a:txBody>
                     <a:bodyPr wrap="square"/>
@@ -7804,7 +7942,7 @@
                           <a:ea typeface="Times New Roman"/>
                           <a:cs typeface="Times New Roman"/>
                         </a:rPr>
-                        <a:t>Original MLP</a:t>
+                        <a:t>Logistic Regression</a:t>
                       </a:r>
                       <a:endParaRPr lang="en-SG" sz="1700"/>
                     </a:p>
@@ -7852,7 +7990,7 @@
                           <a:ea typeface="Times New Roman"/>
                           <a:cs typeface="Times New Roman"/>
                         </a:rPr>
-                        <a:t>64 and 32 hidden neurons, ReLU</a:t>
+                        <a:t>Weights features to estimate career probabilities</a:t>
                       </a:r>
                       <a:endParaRPr lang="en-SG" sz="1700"/>
                     </a:p>
@@ -7875,7 +8013,7 @@
                           <a:ea typeface="Times New Roman"/>
                           <a:cs typeface="Times New Roman"/>
                         </a:rPr>
-                        <a:t>9,014 trainable parameters</a:t>
+                        <a:t>TF-IDF features; regularisation C = 16</a:t>
                       </a:r>
                       <a:endParaRPr lang="en-SG" sz="1700"/>
                     </a:p>
@@ -7901,7 +8039,1021 @@
                   </a:tcPr>
                 </a:tc>
               </a:tr>
-              <a:tr h="640080">
+              <a:tr h="786384">
+                <a:tc>
+                  <a:txBody>
+                    <a:bodyPr wrap="square"/>
+                    <a:lstStyle/>
+                    <a:p>
+                      <a:pPr algn="l">
+                        <a:lnSpc>
+                          <a:spcPct val="105000"/>
+                        </a:lnSpc>
+                        <a:spcAft>
+                          <a:spcPts val="0"/>
+                        </a:spcAft>
+                        <a:buNone/>
+                      </a:pPr>
+                      <a:r>
+                        <a:rPr lang="en-SG" sz="1700" b="0">
+                          <a:solidFill>
+                            <a:srgbClr val="000000"/>
+                          </a:solidFill>
+                          <a:latin typeface="Times New Roman"/>
+                          <a:ea typeface="Times New Roman"/>
+                          <a:cs typeface="Times New Roman"/>
+                        </a:rPr>
+                        <a:t>Random Forest</a:t>
+                      </a:r>
+                      <a:endParaRPr lang="en-SG" sz="1700"/>
+                    </a:p>
+                  </a:txBody>
+                  <a:tcPr marL="91440" marR="91440" marT="45720" marB="45720" anchor="ctr">
+                    <a:lnL w="0">
+                      <a:noFill/>
+                    </a:lnL>
+                    <a:lnR w="0">
+                      <a:noFill/>
+                    </a:lnR>
+                    <a:lnT w="0">
+                      <a:noFill/>
+                    </a:lnT>
+                    <a:lnB w="6350">
+                      <a:solidFill>
+                        <a:srgbClr val="CCD5E0"/>
+                      </a:solidFill>
+                    </a:lnB>
+                    <a:solidFill>
+                      <a:srgbClr val="FFFFFF"/>
+                    </a:solidFill>
+                  </a:tcPr>
+                </a:tc>
+                <a:tc>
+                  <a:txBody>
+                    <a:bodyPr wrap="square"/>
+                    <a:lstStyle/>
+                    <a:p>
+                      <a:pPr algn="l">
+                        <a:lnSpc>
+                          <a:spcPct val="105000"/>
+                        </a:lnSpc>
+                        <a:spcAft>
+                          <a:spcPts val="0"/>
+                        </a:spcAft>
+                        <a:buNone/>
+                      </a:pPr>
+                      <a:r>
+                        <a:rPr lang="en-SG" sz="1700" b="0">
+                          <a:solidFill>
+                            <a:srgbClr val="000000"/>
+                          </a:solidFill>
+                          <a:latin typeface="Times New Roman"/>
+                          <a:ea typeface="Times New Roman"/>
+                          <a:cs typeface="Times New Roman"/>
+                        </a:rPr>
+                        <a:t>Averages predictions from 500 decision trees</a:t>
+                      </a:r>
+                      <a:endParaRPr lang="en-SG" sz="1700"/>
+                    </a:p>
+                    <a:p>
+                      <a:pPr algn="l">
+                        <a:lnSpc>
+                          <a:spcPct val="105000"/>
+                        </a:lnSpc>
+                        <a:spcAft>
+                          <a:spcPts val="0"/>
+                        </a:spcAft>
+                        <a:buNone/>
+                      </a:pPr>
+                      <a:r>
+                        <a:rPr lang="en-SG" sz="1700" b="0">
+                          <a:solidFill>
+                            <a:srgbClr val="000000"/>
+                          </a:solidFill>
+                          <a:latin typeface="Times New Roman"/>
+                          <a:ea typeface="Times New Roman"/>
+                          <a:cs typeface="Times New Roman"/>
+                        </a:rPr>
+                        <a:t>Binary features; minimum 2 profiles per leaf</a:t>
+                      </a:r>
+                      <a:endParaRPr lang="en-SG" sz="1700"/>
+                    </a:p>
+                  </a:txBody>
+                  <a:tcPr marL="91440" marR="91440" marT="45720" marB="45720" anchor="ctr">
+                    <a:lnL w="0">
+                      <a:noFill/>
+                    </a:lnL>
+                    <a:lnR w="0">
+                      <a:noFill/>
+                    </a:lnR>
+                    <a:lnT w="0">
+                      <a:noFill/>
+                    </a:lnT>
+                    <a:lnB w="6350">
+                      <a:solidFill>
+                        <a:srgbClr val="CCD5E0"/>
+                      </a:solidFill>
+                    </a:lnB>
+                    <a:solidFill>
+                      <a:srgbClr val="FFFFFF"/>
+                    </a:solidFill>
+                  </a:tcPr>
+                </a:tc>
+              </a:tr>
+              <a:tr h="786384">
+                <a:tc>
+                  <a:txBody>
+                    <a:bodyPr wrap="square"/>
+                    <a:lstStyle/>
+                    <a:p>
+                      <a:pPr algn="l">
+                        <a:lnSpc>
+                          <a:spcPct val="105000"/>
+                        </a:lnSpc>
+                        <a:spcAft>
+                          <a:spcPts val="0"/>
+                        </a:spcAft>
+                        <a:buNone/>
+                      </a:pPr>
+                      <a:r>
+                        <a:rPr lang="en-SG" sz="1700" b="0">
+                          <a:solidFill>
+                            <a:srgbClr val="000000"/>
+                          </a:solidFill>
+                          <a:latin typeface="Times New Roman"/>
+                          <a:ea typeface="Times New Roman"/>
+                          <a:cs typeface="Times New Roman"/>
+                        </a:rPr>
+                        <a:t>Extra Trees</a:t>
+                      </a:r>
+                      <a:endParaRPr lang="en-SG" sz="1700"/>
+                    </a:p>
+                  </a:txBody>
+                  <a:tcPr marL="91440" marR="91440" marT="45720" marB="45720" anchor="ctr">
+                    <a:lnL w="0">
+                      <a:noFill/>
+                    </a:lnL>
+                    <a:lnR w="0">
+                      <a:noFill/>
+                    </a:lnR>
+                    <a:lnT w="0">
+                      <a:noFill/>
+                    </a:lnT>
+                    <a:lnB w="6350">
+                      <a:solidFill>
+                        <a:srgbClr val="CCD5E0"/>
+                      </a:solidFill>
+                    </a:lnB>
+                    <a:solidFill>
+                      <a:srgbClr val="FFFFFF"/>
+                    </a:solidFill>
+                  </a:tcPr>
+                </a:tc>
+                <a:tc>
+                  <a:txBody>
+                    <a:bodyPr wrap="square"/>
+                    <a:lstStyle/>
+                    <a:p>
+                      <a:pPr algn="l">
+                        <a:lnSpc>
+                          <a:spcPct val="105000"/>
+                        </a:lnSpc>
+                        <a:spcAft>
+                          <a:spcPts val="0"/>
+                        </a:spcAft>
+                        <a:buNone/>
+                      </a:pPr>
+                      <a:r>
+                        <a:rPr lang="en-SG" sz="1700" b="0">
+                          <a:solidFill>
+                            <a:srgbClr val="000000"/>
+                          </a:solidFill>
+                          <a:latin typeface="Times New Roman"/>
+                          <a:ea typeface="Times New Roman"/>
+                          <a:cs typeface="Times New Roman"/>
+                        </a:rPr>
+                        <a:t>500 trees with randomised split thresholds</a:t>
+                      </a:r>
+                      <a:endParaRPr lang="en-SG" sz="1700"/>
+                    </a:p>
+                    <a:p>
+                      <a:pPr algn="l">
+                        <a:lnSpc>
+                          <a:spcPct val="105000"/>
+                        </a:lnSpc>
+                        <a:spcAft>
+                          <a:spcPts val="0"/>
+                        </a:spcAft>
+                        <a:buNone/>
+                      </a:pPr>
+                      <a:r>
+                        <a:rPr lang="en-SG" sz="1700" b="0">
+                          <a:solidFill>
+                            <a:srgbClr val="000000"/>
+                          </a:solidFill>
+                          <a:latin typeface="Times New Roman"/>
+                          <a:ea typeface="Times New Roman"/>
+                          <a:cs typeface="Times New Roman"/>
+                        </a:rPr>
+                        <a:t>Binary features; minimum 2 profiles per leaf</a:t>
+                      </a:r>
+                      <a:endParaRPr lang="en-SG" sz="1700"/>
+                    </a:p>
+                  </a:txBody>
+                  <a:tcPr marL="91440" marR="91440" marT="45720" marB="45720" anchor="ctr">
+                    <a:lnL w="0">
+                      <a:noFill/>
+                    </a:lnL>
+                    <a:lnR w="0">
+                      <a:noFill/>
+                    </a:lnR>
+                    <a:lnT w="0">
+                      <a:noFill/>
+                    </a:lnT>
+                    <a:lnB w="6350">
+                      <a:solidFill>
+                        <a:srgbClr val="CCD5E0"/>
+                      </a:solidFill>
+                    </a:lnB>
+                    <a:solidFill>
+                      <a:srgbClr val="FFFFFF"/>
+                    </a:solidFill>
+                  </a:tcPr>
+                </a:tc>
+              </a:tr>
+            </a:tbl>
+          </a:graphicData>
+        </a:graphic>
+      </p:graphicFrame>
+      <p:sp>
+        <p:nvSpPr>
+          <p:cNvPr id="102" name="Project content 102"/>
+          <p:cNvSpPr txBox="1"/>
+          <p:nvPr/>
+        </p:nvSpPr>
+        <p:spPr>
+          <a:xfrm>
+            <a:off x="594360" y="4279392"/>
+            <a:ext cx="7406640" cy="274320"/>
+          </a:xfrm>
+          <a:prstGeom prst="rect">
+            <a:avLst/>
+          </a:prstGeom>
+          <a:noFill/>
+          <a:ln>
+            <a:noFill/>
+          </a:ln>
+        </p:spPr>
+        <p:txBody>
+          <a:bodyPr wrap="square" lIns="0" rIns="0" tIns="0" bIns="0" anchor="t">
+            <a:noAutofit/>
+          </a:bodyPr>
+          <a:lstStyle/>
+          <a:p>
+            <a:pPr algn="l">
+              <a:lnSpc>
+                <a:spcPct val="105000"/>
+              </a:lnSpc>
+              <a:spcAft>
+                <a:spcPts val="0"/>
+              </a:spcAft>
+              <a:buNone/>
+            </a:pPr>
+            <a:r>
+              <a:rPr lang="en-SG" sz="1700" b="1">
+                <a:solidFill>
+                  <a:srgbClr val="181C62"/>
+                </a:solidFill>
+                <a:latin typeface="Times New Roman"/>
+                <a:ea typeface="Times New Roman"/>
+                <a:cs typeface="Times New Roman"/>
+              </a:rPr>
+              <a:t>Logistic Regression is the model used by the CSV prototype.</a:t>
+            </a:r>
+            <a:endParaRPr lang="en-SG" sz="1700"/>
+          </a:p>
+        </p:txBody>
+      </p:sp>
+      <p:sp>
+        <p:nvSpPr>
+          <p:cNvPr id="103" name="Project content 103"/>
+          <p:cNvSpPr txBox="1"/>
+          <p:nvPr/>
+        </p:nvSpPr>
+        <p:spPr>
+          <a:xfrm>
+            <a:off x="594360" y="4581144"/>
+            <a:ext cx="7406640" cy="256032"/>
+          </a:xfrm>
+          <a:prstGeom prst="rect">
+            <a:avLst/>
+          </a:prstGeom>
+          <a:noFill/>
+          <a:ln>
+            <a:noFill/>
+          </a:ln>
+        </p:spPr>
+        <p:txBody>
+          <a:bodyPr wrap="square" lIns="0" rIns="0" tIns="0" bIns="0" anchor="t">
+            <a:noAutofit/>
+          </a:bodyPr>
+          <a:lstStyle/>
+          <a:p>
+            <a:pPr algn="l">
+              <a:lnSpc>
+                <a:spcPct val="105000"/>
+              </a:lnSpc>
+              <a:spcAft>
+                <a:spcPts val="0"/>
+              </a:spcAft>
+              <a:buNone/>
+            </a:pPr>
+            <a:r>
+              <a:rPr lang="en-SG" sz="1550" b="0">
+                <a:solidFill>
+                  <a:srgbClr val="444444"/>
+                </a:solidFill>
+                <a:latin typeface="Times New Roman"/>
+                <a:ea typeface="Times New Roman"/>
+                <a:cs typeface="Times New Roman"/>
+              </a:rPr>
+              <a:t>Same five stratified folds: 12,000 training and 3,000 test profiles per fold.</a:t>
+            </a:r>
+            <a:endParaRPr lang="en-SG" sz="1550"/>
+          </a:p>
+        </p:txBody>
+      </p:sp>
+    </p:spTree>
+    <p:extLst>
+      <p:ext uri="{BB962C8B-B14F-4D97-AF65-F5344CB8AC3E}">
+        <p14:creationId xmlns:p14="http://schemas.microsoft.com/office/powerpoint/2010/main" val="3833664426"/>
+      </p:ext>
+    </p:extLst>
+  </p:cSld>
+  <p:clrMapOvr>
+    <a:masterClrMapping/>
+  </p:clrMapOvr>
+</p:sld>
+</file>
+
+<file path=ppt/slides/slide12.xml><?xml version="1.0" encoding="utf-8"?>
+<p:sld xmlns:a="http://schemas.openxmlformats.org/drawingml/2006/main" xmlns:r="http://schemas.openxmlformats.org/officeDocument/2006/relationships" xmlns:p="http://schemas.openxmlformats.org/presentationml/2006/main">
+  <p:cSld>
+    <p:spTree>
+      <p:nvGrpSpPr>
+        <p:cNvPr id="1" name="">
+          <a:extLst>
+            <a:ext uri="{FF2B5EF4-FFF2-40B4-BE49-F238E27FC236}">
+              <a16:creationId xmlns:a16="http://schemas.microsoft.com/office/drawing/2014/main" id="{28A2225D-6047-29AB-5998-6B86B367D838}"/>
+            </a:ext>
+          </a:extLst>
+        </p:cNvPr>
+        <p:cNvGrpSpPr/>
+        <p:nvPr/>
+      </p:nvGrpSpPr>
+      <p:grpSpPr>
+        <a:xfrm>
+          <a:off x="0" y="0"/>
+          <a:ext cx="0" cy="0"/>
+          <a:chOff x="0" y="0"/>
+          <a:chExt cx="0" cy="0"/>
+        </a:xfrm>
+      </p:grpSpPr>
+      <p:sp>
+        <p:nvSpPr>
+          <p:cNvPr id="2" name="Title 1">
+            <a:extLst>
+              <a:ext uri="{FF2B5EF4-FFF2-40B4-BE49-F238E27FC236}">
+                <a16:creationId xmlns:a16="http://schemas.microsoft.com/office/drawing/2014/main" id="{0845A0BF-2B84-8CFF-CBB7-DC926978A978}"/>
+              </a:ext>
+            </a:extLst>
+          </p:cNvPr>
+          <p:cNvSpPr>
+            <a:spLocks noGrp="1"/>
+          </p:cNvSpPr>
+          <p:nvPr>
+            <p:ph type="title"/>
+          </p:nvPr>
+        </p:nvSpPr>
+        <p:spPr>
+          <a:xfrm>
+            <a:off x="64929" y="114298"/>
+            <a:ext cx="3238648" cy="554419"/>
+          </a:xfrm>
+        </p:spPr>
+        <p:txBody>
+          <a:bodyPr>
+            <a:noAutofit/>
+          </a:bodyPr>
+          <a:lstStyle/>
+          <a:p>
+            <a:r>
+              <a:rPr lang="en-US" sz="2800" b="1" dirty="0">
+                <a:effectLst>
+                  <a:outerShdw blurRad="38100" dist="38100" dir="2700000" algn="tl">
+                    <a:srgbClr val="000000">
+                      <a:alpha val="43137"/>
+                    </a:srgbClr>
+                  </a:outerShdw>
+                </a:effectLst>
+                <a:latin typeface="Times New Roman" panose="02020603050405020304" pitchFamily="18" charset="0"/>
+                <a:cs typeface="Times New Roman" panose="02020603050405020304" pitchFamily="18" charset="0"/>
+              </a:rPr>
+              <a:t>03 AI Application </a:t>
+            </a:r>
+          </a:p>
+        </p:txBody>
+      </p:sp>
+      <p:sp>
+        <p:nvSpPr>
+          <p:cNvPr id="6" name="Slide Number Placeholder 5">
+            <a:extLst>
+              <a:ext uri="{FF2B5EF4-FFF2-40B4-BE49-F238E27FC236}">
+                <a16:creationId xmlns:a16="http://schemas.microsoft.com/office/drawing/2014/main" id="{253703FC-8D08-CDEA-0E7C-0EACE28E88D3}"/>
+              </a:ext>
+            </a:extLst>
+          </p:cNvPr>
+          <p:cNvSpPr>
+            <a:spLocks noGrp="1"/>
+          </p:cNvSpPr>
+          <p:nvPr>
+            <p:ph type="sldNum" sz="quarter" idx="12"/>
+          </p:nvPr>
+        </p:nvSpPr>
+        <p:spPr>
+          <a:xfrm>
+            <a:off x="6377354" y="4584679"/>
+            <a:ext cx="2133600" cy="273844"/>
+          </a:xfrm>
+        </p:spPr>
+        <p:txBody>
+          <a:bodyPr/>
+          <a:lstStyle/>
+          <a:p>
+            <a:fld id="{8E6562B1-0B0F-0246-9532-09536BC2AE59}" type="slidenum">
+              <a:rPr lang="en-US" smtClean="0"/>
+              <a:t>12</a:t>
+            </a:fld>
+            <a:endParaRPr lang="en-US" dirty="0"/>
+          </a:p>
+        </p:txBody>
+      </p:sp>
+      <p:cxnSp>
+        <p:nvCxnSpPr>
+          <p:cNvPr id="28" name="Straight Connector 27">
+            <a:extLst>
+              <a:ext uri="{FF2B5EF4-FFF2-40B4-BE49-F238E27FC236}">
+                <a16:creationId xmlns:a16="http://schemas.microsoft.com/office/drawing/2014/main" id="{2FBBF38C-951A-E4B7-3783-A279E46BA5D5}"/>
+              </a:ext>
+            </a:extLst>
+          </p:cNvPr>
+          <p:cNvCxnSpPr>
+            <a:cxnSpLocks/>
+          </p:cNvCxnSpPr>
+          <p:nvPr/>
+        </p:nvCxnSpPr>
+        <p:spPr>
+          <a:xfrm>
+            <a:off x="0" y="712002"/>
+            <a:ext cx="9144000" cy="0"/>
+          </a:xfrm>
+          <a:prstGeom prst="line">
+            <a:avLst/>
+          </a:prstGeom>
+          <a:ln>
+            <a:solidFill>
+              <a:schemeClr val="accent1">
+                <a:lumMod val="75000"/>
+              </a:schemeClr>
+            </a:solidFill>
+          </a:ln>
+          <a:effectLst/>
+        </p:spPr>
+        <p:style>
+          <a:lnRef idx="2">
+            <a:schemeClr val="accent1"/>
+          </a:lnRef>
+          <a:fillRef idx="0">
+            <a:schemeClr val="accent1"/>
+          </a:fillRef>
+          <a:effectRef idx="1">
+            <a:schemeClr val="accent1"/>
+          </a:effectRef>
+          <a:fontRef idx="minor">
+            <a:schemeClr val="tx1"/>
+          </a:fontRef>
+        </p:style>
+      </p:cxnSp>
+      <p:sp>
+        <p:nvSpPr>
+          <p:cNvPr id="3" name="직사각형 2">
+            <a:extLst>
+              <a:ext uri="{FF2B5EF4-FFF2-40B4-BE49-F238E27FC236}">
+                <a16:creationId xmlns:a16="http://schemas.microsoft.com/office/drawing/2014/main" id="{C45697B2-C90F-9066-D1B7-989CF25D5FE3}"/>
+              </a:ext>
+            </a:extLst>
+          </p:cNvPr>
+          <p:cNvSpPr/>
+          <p:nvPr/>
+        </p:nvSpPr>
+        <p:spPr>
+          <a:xfrm>
+            <a:off x="8510954" y="0"/>
+            <a:ext cx="633046" cy="4879340"/>
+          </a:xfrm>
+          <a:prstGeom prst="rect">
+            <a:avLst/>
+          </a:prstGeom>
+          <a:solidFill>
+            <a:srgbClr val="0250A1"/>
+          </a:solidFill>
+          <a:ln>
+            <a:noFill/>
+          </a:ln>
+          <a:effectLst/>
+        </p:spPr>
+        <p:style>
+          <a:lnRef idx="1">
+            <a:schemeClr val="accent1"/>
+          </a:lnRef>
+          <a:fillRef idx="3">
+            <a:schemeClr val="accent1"/>
+          </a:fillRef>
+          <a:effectRef idx="2">
+            <a:schemeClr val="accent1"/>
+          </a:effectRef>
+          <a:fontRef idx="minor">
+            <a:schemeClr val="lt1"/>
+          </a:fontRef>
+        </p:style>
+        <p:txBody>
+          <a:bodyPr rtlCol="0" anchor="ctr"/>
+          <a:lstStyle/>
+          <a:p>
+            <a:pPr algn="ctr"/>
+            <a:endParaRPr lang="en-SG" dirty="0">
+              <a:effectLst>
+                <a:outerShdw blurRad="38100" dist="38100" dir="2700000" algn="tl">
+                  <a:srgbClr val="000000">
+                    <a:alpha val="43137"/>
+                  </a:srgbClr>
+                </a:outerShdw>
+              </a:effectLst>
+            </a:endParaRPr>
+          </a:p>
+        </p:txBody>
+      </p:sp>
+      <p:sp>
+        <p:nvSpPr>
+          <p:cNvPr id="12" name="Teardrop 17">
+            <a:extLst>
+              <a:ext uri="{FF2B5EF4-FFF2-40B4-BE49-F238E27FC236}">
+                <a16:creationId xmlns:a16="http://schemas.microsoft.com/office/drawing/2014/main" id="{66CB294B-3264-9096-334F-3EBDCB55E57E}"/>
+              </a:ext>
+            </a:extLst>
+          </p:cNvPr>
+          <p:cNvSpPr/>
+          <p:nvPr/>
+        </p:nvSpPr>
+        <p:spPr>
+          <a:xfrm>
+            <a:off x="559485" y="995841"/>
+            <a:ext cx="311223" cy="311222"/>
+          </a:xfrm>
+          <a:prstGeom prst="teardrop">
+            <a:avLst/>
+          </a:prstGeom>
+          <a:solidFill>
+            <a:srgbClr val="181C62"/>
+          </a:solidFill>
+          <a:ln>
+            <a:noFill/>
+          </a:ln>
+        </p:spPr>
+        <p:style>
+          <a:lnRef idx="2">
+            <a:schemeClr val="accent1">
+              <a:shade val="50000"/>
+            </a:schemeClr>
+          </a:lnRef>
+          <a:fillRef idx="1">
+            <a:schemeClr val="accent1"/>
+          </a:fillRef>
+          <a:effectRef idx="0">
+            <a:schemeClr val="accent1"/>
+          </a:effectRef>
+          <a:fontRef idx="minor">
+            <a:schemeClr val="lt1"/>
+          </a:fontRef>
+        </p:style>
+        <p:txBody>
+          <a:bodyPr wrap="none" lIns="0" rIns="0" anchor="ctr">
+            <a:normAutofit fontScale="55000" lnSpcReduction="20000"/>
+            <a:scene3d>
+              <a:camera prst="orthographicFront"/>
+              <a:lightRig rig="threePt" dir="t"/>
+            </a:scene3d>
+            <a:sp3d contourW="12700"/>
+          </a:bodyPr>
+          <a:lstStyle/>
+          <a:p>
+            <a:pPr algn="ctr"/>
+            <a:endParaRPr lang="en-US" b="1" spc="-100" dirty="0">
+              <a:solidFill>
+                <a:schemeClr val="bg1"/>
+              </a:solidFill>
+              <a:latin typeface="Arial" panose="020B0604020202020204" pitchFamily="34" charset="0"/>
+              <a:cs typeface="Arial" panose="020B0604020202020204" pitchFamily="34" charset="0"/>
+            </a:endParaRPr>
+          </a:p>
+        </p:txBody>
+      </p:sp>
+      <p:sp>
+        <p:nvSpPr>
+          <p:cNvPr id="15" name="TextBox 14">
+            <a:extLst>
+              <a:ext uri="{FF2B5EF4-FFF2-40B4-BE49-F238E27FC236}">
+                <a16:creationId xmlns:a16="http://schemas.microsoft.com/office/drawing/2014/main" id="{E0E008A0-D52C-BF35-EF13-081021D2FB22}"/>
+              </a:ext>
+            </a:extLst>
+          </p:cNvPr>
+          <p:cNvSpPr txBox="1"/>
+          <p:nvPr/>
+        </p:nvSpPr>
+        <p:spPr>
+          <a:xfrm rot="5400000">
+            <a:off x="8388092" y="385128"/>
+            <a:ext cx="878767" cy="261610"/>
+          </a:xfrm>
+          <a:prstGeom prst="rect">
+            <a:avLst/>
+          </a:prstGeom>
+          <a:noFill/>
+        </p:spPr>
+        <p:txBody>
+          <a:bodyPr wrap="none" rtlCol="0">
+            <a:spAutoFit/>
+          </a:bodyPr>
+          <a:lstStyle/>
+          <a:p>
+            <a:r>
+              <a:rPr lang="en-SG" sz="1100" dirty="0">
+                <a:latin typeface="Times New Roman" panose="02020603050405020304" pitchFamily="18" charset="0"/>
+                <a:cs typeface="Times New Roman" panose="02020603050405020304" pitchFamily="18" charset="0"/>
+              </a:rPr>
+              <a:t>Introduction</a:t>
+            </a:r>
+          </a:p>
+        </p:txBody>
+      </p:sp>
+      <p:sp>
+        <p:nvSpPr>
+          <p:cNvPr id="20" name="TextBox 19">
+            <a:extLst>
+              <a:ext uri="{FF2B5EF4-FFF2-40B4-BE49-F238E27FC236}">
+                <a16:creationId xmlns:a16="http://schemas.microsoft.com/office/drawing/2014/main" id="{32039CD6-274D-8135-673B-26A04AE1C5F8}"/>
+              </a:ext>
+            </a:extLst>
+          </p:cNvPr>
+          <p:cNvSpPr txBox="1"/>
+          <p:nvPr/>
+        </p:nvSpPr>
+        <p:spPr>
+          <a:xfrm rot="5400000">
+            <a:off x="8356032" y="1274739"/>
+            <a:ext cx="942887" cy="261610"/>
+          </a:xfrm>
+          <a:prstGeom prst="rect">
+            <a:avLst/>
+          </a:prstGeom>
+          <a:noFill/>
+        </p:spPr>
+        <p:txBody>
+          <a:bodyPr wrap="none" rtlCol="0">
+            <a:spAutoFit/>
+          </a:bodyPr>
+          <a:lstStyle/>
+          <a:p>
+            <a:r>
+              <a:rPr lang="en-SG" sz="1100" dirty="0">
+                <a:latin typeface="Times New Roman" panose="02020603050405020304" pitchFamily="18" charset="0"/>
+                <a:cs typeface="Times New Roman" panose="02020603050405020304" pitchFamily="18" charset="0"/>
+              </a:rPr>
+              <a:t>Methodology</a:t>
+            </a:r>
+          </a:p>
+        </p:txBody>
+      </p:sp>
+      <p:sp>
+        <p:nvSpPr>
+          <p:cNvPr id="22" name="TextBox 21">
+            <a:extLst>
+              <a:ext uri="{FF2B5EF4-FFF2-40B4-BE49-F238E27FC236}">
+                <a16:creationId xmlns:a16="http://schemas.microsoft.com/office/drawing/2014/main" id="{EF03D6BD-FC2C-1F2D-6716-8E111EE368E8}"/>
+              </a:ext>
+            </a:extLst>
+          </p:cNvPr>
+          <p:cNvSpPr txBox="1"/>
+          <p:nvPr/>
+        </p:nvSpPr>
+        <p:spPr>
+          <a:xfrm rot="5400000">
+            <a:off x="8287102" y="2205227"/>
+            <a:ext cx="1080745" cy="261610"/>
+          </a:xfrm>
+          <a:prstGeom prst="rect">
+            <a:avLst/>
+          </a:prstGeom>
+          <a:noFill/>
+        </p:spPr>
+        <p:txBody>
+          <a:bodyPr wrap="none" rtlCol="0">
+            <a:spAutoFit/>
+          </a:bodyPr>
+          <a:lstStyle/>
+          <a:p>
+            <a:r>
+              <a:rPr lang="en-SG" sz="1100" b="1" dirty="0">
+                <a:solidFill>
+                  <a:schemeClr val="bg1"/>
+                </a:solidFill>
+                <a:latin typeface="Times New Roman" panose="02020603050405020304" pitchFamily="18" charset="0"/>
+                <a:cs typeface="Times New Roman" panose="02020603050405020304" pitchFamily="18" charset="0"/>
+              </a:rPr>
+              <a:t>AI Application</a:t>
+            </a:r>
+          </a:p>
+        </p:txBody>
+      </p:sp>
+      <p:sp>
+        <p:nvSpPr>
+          <p:cNvPr id="24" name="TextBox 23">
+            <a:extLst>
+              <a:ext uri="{FF2B5EF4-FFF2-40B4-BE49-F238E27FC236}">
+                <a16:creationId xmlns:a16="http://schemas.microsoft.com/office/drawing/2014/main" id="{EA7159A7-2980-1C5C-A36C-46E66BC9E6DD}"/>
+              </a:ext>
+            </a:extLst>
+          </p:cNvPr>
+          <p:cNvSpPr txBox="1"/>
+          <p:nvPr/>
+        </p:nvSpPr>
+        <p:spPr>
+          <a:xfrm rot="5400000">
+            <a:off x="8523546" y="2952171"/>
+            <a:ext cx="607859" cy="261610"/>
+          </a:xfrm>
+          <a:prstGeom prst="rect">
+            <a:avLst/>
+          </a:prstGeom>
+          <a:noFill/>
+        </p:spPr>
+        <p:txBody>
+          <a:bodyPr wrap="none" rtlCol="0">
+            <a:spAutoFit/>
+          </a:bodyPr>
+          <a:lstStyle/>
+          <a:p>
+            <a:r>
+              <a:rPr lang="en-SG" sz="1100" dirty="0">
+                <a:latin typeface="Times New Roman" panose="02020603050405020304" pitchFamily="18" charset="0"/>
+                <a:cs typeface="Times New Roman" panose="02020603050405020304" pitchFamily="18" charset="0"/>
+              </a:rPr>
+              <a:t>Results</a:t>
+            </a:r>
+          </a:p>
+        </p:txBody>
+      </p:sp>
+      <p:sp>
+        <p:nvSpPr>
+          <p:cNvPr id="26" name="TextBox 25">
+            <a:extLst>
+              <a:ext uri="{FF2B5EF4-FFF2-40B4-BE49-F238E27FC236}">
+                <a16:creationId xmlns:a16="http://schemas.microsoft.com/office/drawing/2014/main" id="{58FB5C2C-5C22-A92B-F77B-1189F648E37D}"/>
+              </a:ext>
+            </a:extLst>
+          </p:cNvPr>
+          <p:cNvSpPr txBox="1"/>
+          <p:nvPr/>
+        </p:nvSpPr>
+        <p:spPr>
+          <a:xfrm rot="5400000">
+            <a:off x="8428969" y="3581294"/>
+            <a:ext cx="797013" cy="261610"/>
+          </a:xfrm>
+          <a:prstGeom prst="rect">
+            <a:avLst/>
+          </a:prstGeom>
+          <a:noFill/>
+        </p:spPr>
+        <p:txBody>
+          <a:bodyPr wrap="none" rtlCol="0">
+            <a:spAutoFit/>
+          </a:bodyPr>
+          <a:lstStyle/>
+          <a:p>
+            <a:r>
+              <a:rPr lang="en-SG" sz="1100" dirty="0">
+                <a:latin typeface="Times New Roman" panose="02020603050405020304" pitchFamily="18" charset="0"/>
+                <a:cs typeface="Times New Roman" panose="02020603050405020304" pitchFamily="18" charset="0"/>
+              </a:rPr>
+              <a:t>Discussion</a:t>
+            </a:r>
+          </a:p>
+        </p:txBody>
+      </p:sp>
+      <p:sp>
+        <p:nvSpPr>
+          <p:cNvPr id="29" name="TextBox 28">
+            <a:extLst>
+              <a:ext uri="{FF2B5EF4-FFF2-40B4-BE49-F238E27FC236}">
+                <a16:creationId xmlns:a16="http://schemas.microsoft.com/office/drawing/2014/main" id="{0FBAA057-D595-210D-6A6A-87751E409B08}"/>
+              </a:ext>
+            </a:extLst>
+          </p:cNvPr>
+          <p:cNvSpPr txBox="1"/>
+          <p:nvPr/>
+        </p:nvSpPr>
+        <p:spPr>
+          <a:xfrm rot="5400000">
+            <a:off x="8416145" y="4317816"/>
+            <a:ext cx="822661" cy="261610"/>
+          </a:xfrm>
+          <a:prstGeom prst="rect">
+            <a:avLst/>
+          </a:prstGeom>
+          <a:noFill/>
+        </p:spPr>
+        <p:txBody>
+          <a:bodyPr wrap="none" rtlCol="0">
+            <a:spAutoFit/>
+          </a:bodyPr>
+          <a:lstStyle/>
+          <a:p>
+            <a:r>
+              <a:rPr lang="en-SG" sz="1100" dirty="0">
+                <a:latin typeface="Times New Roman" panose="02020603050405020304" pitchFamily="18" charset="0"/>
+                <a:cs typeface="Times New Roman" panose="02020603050405020304" pitchFamily="18" charset="0"/>
+              </a:rPr>
+              <a:t>Conclusion</a:t>
+            </a:r>
+          </a:p>
+        </p:txBody>
+      </p:sp>
+      <p:sp>
+        <p:nvSpPr>
+          <p:cNvPr id="30" name="TextBox 29">
+            <a:extLst>
+              <a:ext uri="{FF2B5EF4-FFF2-40B4-BE49-F238E27FC236}">
+                <a16:creationId xmlns:a16="http://schemas.microsoft.com/office/drawing/2014/main" id="{9948C935-4D1C-A1A4-C8BE-5AEC59739CD7}"/>
+              </a:ext>
+            </a:extLst>
+          </p:cNvPr>
+          <p:cNvSpPr txBox="1"/>
+          <p:nvPr/>
+        </p:nvSpPr>
+        <p:spPr>
+          <a:xfrm>
+            <a:off x="870708" y="937730"/>
+            <a:ext cx="6500000" cy="369332"/>
+          </a:xfrm>
+          <a:prstGeom prst="rect">
+            <a:avLst/>
+          </a:prstGeom>
+          <a:noFill/>
+        </p:spPr>
+        <p:txBody>
+          <a:bodyPr wrap="none" rtlCol="0">
+            <a:spAutoFit/>
+          </a:bodyPr>
+          <a:lstStyle/>
+          <a:p>
+            <a:r>
+              <a:rPr lang="en-SG" b="1" dirty="0">
+                <a:latin typeface="Times New Roman" panose="02020603050405020304" pitchFamily="18" charset="0"/>
+                <a:cs typeface="Times New Roman" panose="02020603050405020304" pitchFamily="18" charset="0"/>
+              </a:rPr>
+              <a:t>Deep learning models</a:t>
+            </a:r>
+          </a:p>
+        </p:txBody>
+      </p:sp>
+      <p:graphicFrame>
+        <p:nvGraphicFramePr>
+          <p:cNvPr id="101" name="Editable project table 101"/>
+          <p:cNvGraphicFramePr/>
+          <p:nvPr/>
+        </p:nvGraphicFramePr>
+        <p:xfrm>
+          <a:off x="594360" y="1463040"/>
+          <a:ext cx="7406640" cy="2221992"/>
+        </p:xfrm>
+        <a:graphic>
+          <a:graphicData uri="http://schemas.openxmlformats.org/drawingml/2006/table">
+            <a:tbl>
+              <a:tblPr firstRow="1" bandRow="0"/>
+              <a:tblGrid>
+                <a:gridCol w="2148840"/>
+                <a:gridCol w="5257800"/>
+              </a:tblGrid>
+              <a:tr h="393192">
+                <a:tc>
+                  <a:txBody>
+                    <a:bodyPr wrap="square"/>
+                    <a:lstStyle/>
+                    <a:p>
+                      <a:pPr algn="l">
+                        <a:lnSpc>
+                          <a:spcPct val="105000"/>
+                        </a:lnSpc>
+                        <a:spcAft>
+                          <a:spcPts val="0"/>
+                        </a:spcAft>
+                        <a:buNone/>
+                      </a:pPr>
+                      <a:r>
+                        <a:rPr lang="en-SG" sz="1700" b="1">
+                          <a:solidFill>
+                            <a:srgbClr val="FFFFFF"/>
+                          </a:solidFill>
+                          <a:latin typeface="Times New Roman"/>
+                          <a:ea typeface="Times New Roman"/>
+                          <a:cs typeface="Times New Roman"/>
+                        </a:rPr>
+                        <a:t>Model</a:t>
+                      </a:r>
+                      <a:endParaRPr lang="en-SG" sz="1700"/>
+                    </a:p>
+                  </a:txBody>
+                  <a:tcPr marL="91440" marR="91440" marT="45720" marB="45720" anchor="ctr">
+                    <a:lnL w="0">
+                      <a:noFill/>
+                    </a:lnL>
+                    <a:lnR w="0">
+                      <a:noFill/>
+                    </a:lnR>
+                    <a:lnT w="0">
+                      <a:noFill/>
+                    </a:lnT>
+                    <a:lnB w="6350">
+                      <a:solidFill>
+                        <a:srgbClr val="CCD5E0"/>
+                      </a:solidFill>
+                    </a:lnB>
+                    <a:solidFill>
+                      <a:srgbClr val="181C62"/>
+                    </a:solidFill>
+                  </a:tcPr>
+                </a:tc>
+                <a:tc>
+                  <a:txBody>
+                    <a:bodyPr wrap="square"/>
+                    <a:lstStyle/>
+                    <a:p>
+                      <a:pPr algn="l">
+                        <a:lnSpc>
+                          <a:spcPct val="105000"/>
+                        </a:lnSpc>
+                        <a:spcAft>
+                          <a:spcPts val="0"/>
+                        </a:spcAft>
+                        <a:buNone/>
+                      </a:pPr>
+                      <a:r>
+                        <a:rPr lang="en-SG" sz="1700" b="1">
+                          <a:solidFill>
+                            <a:srgbClr val="FFFFFF"/>
+                          </a:solidFill>
+                          <a:latin typeface="Times New Roman"/>
+                          <a:ea typeface="Times New Roman"/>
+                          <a:cs typeface="Times New Roman"/>
+                        </a:rPr>
+                        <a:t>How it works and architecture tested</a:t>
+                      </a:r>
+                      <a:endParaRPr lang="en-SG" sz="1700"/>
+                    </a:p>
+                  </a:txBody>
+                  <a:tcPr marL="91440" marR="91440" marT="45720" marB="45720" anchor="ctr">
+                    <a:lnL w="0">
+                      <a:noFill/>
+                    </a:lnL>
+                    <a:lnR w="0">
+                      <a:noFill/>
+                    </a:lnR>
+                    <a:lnT w="0">
+                      <a:noFill/>
+                    </a:lnT>
+                    <a:lnB w="6350">
+                      <a:solidFill>
+                        <a:srgbClr val="CCD5E0"/>
+                      </a:solidFill>
+                    </a:lnB>
+                    <a:solidFill>
+                      <a:srgbClr val="181C62"/>
+                    </a:solidFill>
+                  </a:tcPr>
+                </a:tc>
+              </a:tr>
+              <a:tr h="914400">
                 <a:tc>
                   <a:txBody>
                     <a:bodyPr wrap="square"/>
@@ -7973,7 +9125,7 @@
                           <a:ea typeface="Times New Roman"/>
                           <a:cs typeface="Times New Roman"/>
                         </a:rPr>
-                        <a:t>3 or 5 hidden layers, GELU and LayerNorm</a:t>
+                        <a:t>3 or 5 hidden layers learn nonlinear patterns</a:t>
                       </a:r>
                       <a:endParaRPr lang="en-SG" sz="1700"/>
                     </a:p>
@@ -7996,7 +9148,7 @@
                           <a:ea typeface="Times New Roman"/>
                           <a:cs typeface="Times New Roman"/>
                         </a:rPr>
-                        <a:t>68,310–226,934 parameters</a:t>
+                        <a:t>GELU, LayerNorm; 68,310 to 226,934 parameters</a:t>
                       </a:r>
                       <a:endParaRPr lang="en-SG" sz="1700"/>
                     </a:p>
@@ -8022,128 +9174,7 @@
                   </a:tcPr>
                 </a:tc>
               </a:tr>
-              <a:tr h="640080">
-                <a:tc>
-                  <a:txBody>
-                    <a:bodyPr wrap="square"/>
-                    <a:lstStyle/>
-                    <a:p>
-                      <a:pPr algn="l">
-                        <a:lnSpc>
-                          <a:spcPct val="105000"/>
-                        </a:lnSpc>
-                        <a:spcAft>
-                          <a:spcPts val="0"/>
-                        </a:spcAft>
-                        <a:buNone/>
-                      </a:pPr>
-                      <a:r>
-                        <a:rPr lang="en-SG" sz="1700" b="0">
-                          <a:solidFill>
-                            <a:srgbClr val="000000"/>
-                          </a:solidFill>
-                          <a:latin typeface="Times New Roman"/>
-                          <a:ea typeface="Times New Roman"/>
-                          <a:cs typeface="Times New Roman"/>
-                        </a:rPr>
-                        <a:t>Residual network</a:t>
-                      </a:r>
-                      <a:endParaRPr lang="en-SG" sz="1700"/>
-                    </a:p>
-                  </a:txBody>
-                  <a:tcPr marL="91440" marR="91440" marT="45720" marB="45720" anchor="ctr">
-                    <a:lnL w="0">
-                      <a:noFill/>
-                    </a:lnL>
-                    <a:lnR w="0">
-                      <a:noFill/>
-                    </a:lnR>
-                    <a:lnT w="0">
-                      <a:noFill/>
-                    </a:lnT>
-                    <a:lnB w="6350">
-                      <a:solidFill>
-                        <a:srgbClr val="CCD5E0"/>
-                      </a:solidFill>
-                    </a:lnB>
-                    <a:solidFill>
-                      <a:srgbClr val="FFFFFF"/>
-                    </a:solidFill>
-                  </a:tcPr>
-                </a:tc>
-                <a:tc>
-                  <a:txBody>
-                    <a:bodyPr wrap="square"/>
-                    <a:lstStyle/>
-                    <a:p>
-                      <a:pPr algn="l">
-                        <a:lnSpc>
-                          <a:spcPct val="105000"/>
-                        </a:lnSpc>
-                        <a:spcAft>
-                          <a:spcPts val="0"/>
-                        </a:spcAft>
-                        <a:buNone/>
-                      </a:pPr>
-                      <a:r>
-                        <a:rPr lang="en-SG" sz="1700" b="0">
-                          <a:solidFill>
-                            <a:srgbClr val="000000"/>
-                          </a:solidFill>
-                          <a:latin typeface="Times New Roman"/>
-                          <a:ea typeface="Times New Roman"/>
-                          <a:cs typeface="Times New Roman"/>
-                        </a:rPr>
-                        <a:t>2–4 blocks with skip connections</a:t>
-                      </a:r>
-                      <a:endParaRPr lang="en-SG" sz="1700"/>
-                    </a:p>
-                    <a:p>
-                      <a:pPr algn="l">
-                        <a:lnSpc>
-                          <a:spcPct val="105000"/>
-                        </a:lnSpc>
-                        <a:spcAft>
-                          <a:spcPts val="0"/>
-                        </a:spcAft>
-                        <a:buNone/>
-                      </a:pPr>
-                      <a:r>
-                        <a:rPr lang="en-SG" sz="1700" b="0">
-                          <a:solidFill>
-                            <a:srgbClr val="000000"/>
-                          </a:solidFill>
-                          <a:latin typeface="Times New Roman"/>
-                          <a:ea typeface="Times New Roman"/>
-                          <a:cs typeface="Times New Roman"/>
-                        </a:rPr>
-                        <a:t>147,862–821,270 parameters</a:t>
-                      </a:r>
-                      <a:endParaRPr lang="en-SG" sz="1700"/>
-                    </a:p>
-                  </a:txBody>
-                  <a:tcPr marL="91440" marR="91440" marT="45720" marB="45720" anchor="ctr">
-                    <a:lnL w="0">
-                      <a:noFill/>
-                    </a:lnL>
-                    <a:lnR w="0">
-                      <a:noFill/>
-                    </a:lnR>
-                    <a:lnT w="0">
-                      <a:noFill/>
-                    </a:lnT>
-                    <a:lnB w="6350">
-                      <a:solidFill>
-                        <a:srgbClr val="CCD5E0"/>
-                      </a:solidFill>
-                    </a:lnB>
-                    <a:solidFill>
-                      <a:srgbClr val="FFFFFF"/>
-                    </a:solidFill>
-                  </a:tcPr>
-                </a:tc>
-              </a:tr>
-              <a:tr h="640080">
+              <a:tr h="914400">
                 <a:tc>
                   <a:txBody>
                     <a:bodyPr wrap="square"/>
@@ -8215,7 +9246,7 @@
                           <a:ea typeface="Times New Roman"/>
                           <a:cs typeface="Times New Roman"/>
                         </a:rPr>
-                        <a:t>18 field tokens, 4 attention heads, 2 or 4 blocks</a:t>
+                        <a:t>Attention combines information from 18 field tokens</a:t>
                       </a:r>
                       <a:endParaRPr lang="en-SG" sz="1700"/>
                     </a:p>
@@ -8238,7 +9269,7 @@
                           <a:ea typeface="Times New Roman"/>
                           <a:cs typeface="Times New Roman"/>
                         </a:rPr>
-                        <a:t>29,878–108,886 parameters</a:t>
+                        <a:t>4 heads, 2 or 4 blocks; 29,878 to 108,886 parameters</a:t>
                       </a:r>
                       <a:endParaRPr lang="en-SG" sz="1700"/>
                     </a:p>
@@ -8276,8 +9307,8 @@
         </p:nvSpPr>
         <p:spPr>
           <a:xfrm>
-            <a:off x="594360" y="4553712"/>
-            <a:ext cx="7406640" cy="320040"/>
+            <a:off x="594360" y="3840480"/>
+            <a:ext cx="7406640" cy="292608"/>
           </a:xfrm>
           <a:prstGeom prst="rect">
             <a:avLst/>
@@ -8303,1188 +9334,30 @@
               <a:buNone/>
             </a:pPr>
             <a:r>
-              <a:rPr lang="en-SG" sz="1650" b="1">
+              <a:rPr lang="en-SG" sz="1700" b="0">
                 <a:solidFill>
-                  <a:srgbClr val="181C62"/>
+                  <a:srgbClr val="000000"/>
                 </a:solidFill>
                 <a:latin typeface="Times New Roman"/>
                 <a:ea typeface="Times New Roman"/>
                 <a:cs typeface="Times New Roman"/>
               </a:rPr>
-              <a:t>96 encoded inputs and 22 career outputs. Reference: Logistic Regression.</a:t>
-            </a:r>
-            <a:endParaRPr lang="en-SG" sz="1650"/>
-          </a:p>
-        </p:txBody>
-      </p:sp>
-    </p:spTree>
-    <p:extLst>
-      <p:ext uri="{BB962C8B-B14F-4D97-AF65-F5344CB8AC3E}">
-        <p14:creationId xmlns:p14="http://schemas.microsoft.com/office/powerpoint/2010/main" val="3833664426"/>
-      </p:ext>
-    </p:extLst>
-  </p:cSld>
-  <p:clrMapOvr>
-    <a:masterClrMapping/>
-  </p:clrMapOvr>
-</p:sld>
-</file>
-
-<file path=ppt/slides/slide12.xml><?xml version="1.0" encoding="utf-8"?>
-<p:sld xmlns:a="http://schemas.openxmlformats.org/drawingml/2006/main" xmlns:r="http://schemas.openxmlformats.org/officeDocument/2006/relationships" xmlns:p="http://schemas.openxmlformats.org/presentationml/2006/main">
-  <p:cSld>
-    <p:spTree>
-      <p:nvGrpSpPr>
-        <p:cNvPr id="1" name="">
-          <a:extLst>
-            <a:ext uri="{FF2B5EF4-FFF2-40B4-BE49-F238E27FC236}">
-              <a16:creationId xmlns:a16="http://schemas.microsoft.com/office/drawing/2014/main" id="{28A2225D-6047-29AB-5998-6B86B367D838}"/>
-            </a:ext>
-          </a:extLst>
-        </p:cNvPr>
-        <p:cNvGrpSpPr/>
-        <p:nvPr/>
-      </p:nvGrpSpPr>
-      <p:grpSpPr>
-        <a:xfrm>
-          <a:off x="0" y="0"/>
-          <a:ext cx="0" cy="0"/>
-          <a:chOff x="0" y="0"/>
-          <a:chExt cx="0" cy="0"/>
-        </a:xfrm>
-      </p:grpSpPr>
-      <p:sp>
-        <p:nvSpPr>
-          <p:cNvPr id="2" name="Title 1">
-            <a:extLst>
-              <a:ext uri="{FF2B5EF4-FFF2-40B4-BE49-F238E27FC236}">
-                <a16:creationId xmlns:a16="http://schemas.microsoft.com/office/drawing/2014/main" id="{0845A0BF-2B84-8CFF-CBB7-DC926978A978}"/>
-              </a:ext>
-            </a:extLst>
-          </p:cNvPr>
-          <p:cNvSpPr>
-            <a:spLocks noGrp="1"/>
-          </p:cNvSpPr>
-          <p:nvPr>
-            <p:ph type="title"/>
-          </p:nvPr>
-        </p:nvSpPr>
-        <p:spPr>
-          <a:xfrm>
-            <a:off x="64929" y="114298"/>
-            <a:ext cx="3238648" cy="554419"/>
-          </a:xfrm>
-        </p:spPr>
-        <p:txBody>
-          <a:bodyPr>
-            <a:noAutofit/>
-          </a:bodyPr>
-          <a:lstStyle/>
-          <a:p>
-            <a:r>
-              <a:rPr lang="en-US" sz="2800" b="1" dirty="0">
-                <a:effectLst>
-                  <a:outerShdw blurRad="38100" dist="38100" dir="2700000" algn="tl">
-                    <a:srgbClr val="000000">
-                      <a:alpha val="43137"/>
-                    </a:srgbClr>
-                  </a:outerShdw>
-                </a:effectLst>
-                <a:latin typeface="Times New Roman" panose="02020603050405020304" pitchFamily="18" charset="0"/>
-                <a:cs typeface="Times New Roman" panose="02020603050405020304" pitchFamily="18" charset="0"/>
-              </a:rPr>
-              <a:t>03 AI Application </a:t>
-            </a:r>
-          </a:p>
-        </p:txBody>
-      </p:sp>
-      <p:sp>
-        <p:nvSpPr>
-          <p:cNvPr id="6" name="Slide Number Placeholder 5">
-            <a:extLst>
-              <a:ext uri="{FF2B5EF4-FFF2-40B4-BE49-F238E27FC236}">
-                <a16:creationId xmlns:a16="http://schemas.microsoft.com/office/drawing/2014/main" id="{253703FC-8D08-CDEA-0E7C-0EACE28E88D3}"/>
-              </a:ext>
-            </a:extLst>
-          </p:cNvPr>
-          <p:cNvSpPr>
-            <a:spLocks noGrp="1"/>
-          </p:cNvSpPr>
-          <p:nvPr>
-            <p:ph type="sldNum" sz="quarter" idx="12"/>
-          </p:nvPr>
-        </p:nvSpPr>
-        <p:spPr>
-          <a:xfrm>
-            <a:off x="6377354" y="4584679"/>
-            <a:ext cx="2133600" cy="273844"/>
-          </a:xfrm>
-        </p:spPr>
-        <p:txBody>
-          <a:bodyPr/>
-          <a:lstStyle/>
-          <a:p>
-            <a:fld id="{8E6562B1-0B0F-0246-9532-09536BC2AE59}" type="slidenum">
-              <a:rPr lang="en-US" smtClean="0"/>
-              <a:t>12</a:t>
-            </a:fld>
-            <a:endParaRPr lang="en-US" dirty="0"/>
-          </a:p>
-        </p:txBody>
-      </p:sp>
-      <p:cxnSp>
-        <p:nvCxnSpPr>
-          <p:cNvPr id="28" name="Straight Connector 27">
-            <a:extLst>
-              <a:ext uri="{FF2B5EF4-FFF2-40B4-BE49-F238E27FC236}">
-                <a16:creationId xmlns:a16="http://schemas.microsoft.com/office/drawing/2014/main" id="{2FBBF38C-951A-E4B7-3783-A279E46BA5D5}"/>
-              </a:ext>
-            </a:extLst>
-          </p:cNvPr>
-          <p:cNvCxnSpPr>
-            <a:cxnSpLocks/>
-          </p:cNvCxnSpPr>
-          <p:nvPr/>
-        </p:nvCxnSpPr>
-        <p:spPr>
-          <a:xfrm>
-            <a:off x="0" y="712002"/>
-            <a:ext cx="9144000" cy="0"/>
-          </a:xfrm>
-          <a:prstGeom prst="line">
-            <a:avLst/>
-          </a:prstGeom>
-          <a:ln>
-            <a:solidFill>
-              <a:schemeClr val="accent1">
-                <a:lumMod val="75000"/>
-              </a:schemeClr>
-            </a:solidFill>
-          </a:ln>
-          <a:effectLst/>
-        </p:spPr>
-        <p:style>
-          <a:lnRef idx="2">
-            <a:schemeClr val="accent1"/>
-          </a:lnRef>
-          <a:fillRef idx="0">
-            <a:schemeClr val="accent1"/>
-          </a:fillRef>
-          <a:effectRef idx="1">
-            <a:schemeClr val="accent1"/>
-          </a:effectRef>
-          <a:fontRef idx="minor">
-            <a:schemeClr val="tx1"/>
-          </a:fontRef>
-        </p:style>
-      </p:cxnSp>
-      <p:sp>
-        <p:nvSpPr>
-          <p:cNvPr id="3" name="직사각형 2">
-            <a:extLst>
-              <a:ext uri="{FF2B5EF4-FFF2-40B4-BE49-F238E27FC236}">
-                <a16:creationId xmlns:a16="http://schemas.microsoft.com/office/drawing/2014/main" id="{C45697B2-C90F-9066-D1B7-989CF25D5FE3}"/>
-              </a:ext>
-            </a:extLst>
-          </p:cNvPr>
-          <p:cNvSpPr/>
-          <p:nvPr/>
-        </p:nvSpPr>
-        <p:spPr>
-          <a:xfrm>
-            <a:off x="8510954" y="0"/>
-            <a:ext cx="633046" cy="4879340"/>
-          </a:xfrm>
-          <a:prstGeom prst="rect">
-            <a:avLst/>
-          </a:prstGeom>
-          <a:solidFill>
-            <a:srgbClr val="0250A1"/>
-          </a:solidFill>
-          <a:ln>
-            <a:noFill/>
-          </a:ln>
-          <a:effectLst/>
-        </p:spPr>
-        <p:style>
-          <a:lnRef idx="1">
-            <a:schemeClr val="accent1"/>
-          </a:lnRef>
-          <a:fillRef idx="3">
-            <a:schemeClr val="accent1"/>
-          </a:fillRef>
-          <a:effectRef idx="2">
-            <a:schemeClr val="accent1"/>
-          </a:effectRef>
-          <a:fontRef idx="minor">
-            <a:schemeClr val="lt1"/>
-          </a:fontRef>
-        </p:style>
-        <p:txBody>
-          <a:bodyPr rtlCol="0" anchor="ctr"/>
-          <a:lstStyle/>
-          <a:p>
-            <a:pPr algn="ctr"/>
-            <a:endParaRPr lang="en-SG" dirty="0">
-              <a:effectLst>
-                <a:outerShdw blurRad="38100" dist="38100" dir="2700000" algn="tl">
-                  <a:srgbClr val="000000">
-                    <a:alpha val="43137"/>
-                  </a:srgbClr>
-                </a:outerShdw>
-              </a:effectLst>
-            </a:endParaRPr>
-          </a:p>
-        </p:txBody>
-      </p:sp>
-      <p:sp>
-        <p:nvSpPr>
-          <p:cNvPr id="12" name="Teardrop 17">
-            <a:extLst>
-              <a:ext uri="{FF2B5EF4-FFF2-40B4-BE49-F238E27FC236}">
-                <a16:creationId xmlns:a16="http://schemas.microsoft.com/office/drawing/2014/main" id="{66CB294B-3264-9096-334F-3EBDCB55E57E}"/>
-              </a:ext>
-            </a:extLst>
-          </p:cNvPr>
-          <p:cNvSpPr/>
-          <p:nvPr/>
-        </p:nvSpPr>
-        <p:spPr>
-          <a:xfrm>
-            <a:off x="559485" y="995841"/>
-            <a:ext cx="311223" cy="311222"/>
-          </a:xfrm>
-          <a:prstGeom prst="teardrop">
-            <a:avLst/>
-          </a:prstGeom>
-          <a:solidFill>
-            <a:srgbClr val="181C62"/>
-          </a:solidFill>
-          <a:ln>
-            <a:noFill/>
-          </a:ln>
-        </p:spPr>
-        <p:style>
-          <a:lnRef idx="2">
-            <a:schemeClr val="accent1">
-              <a:shade val="50000"/>
-            </a:schemeClr>
-          </a:lnRef>
-          <a:fillRef idx="1">
-            <a:schemeClr val="accent1"/>
-          </a:fillRef>
-          <a:effectRef idx="0">
-            <a:schemeClr val="accent1"/>
-          </a:effectRef>
-          <a:fontRef idx="minor">
-            <a:schemeClr val="lt1"/>
-          </a:fontRef>
-        </p:style>
-        <p:txBody>
-          <a:bodyPr wrap="none" lIns="0" rIns="0" anchor="ctr">
-            <a:normAutofit fontScale="55000" lnSpcReduction="20000"/>
-            <a:scene3d>
-              <a:camera prst="orthographicFront"/>
-              <a:lightRig rig="threePt" dir="t"/>
-            </a:scene3d>
-            <a:sp3d contourW="12700"/>
-          </a:bodyPr>
-          <a:lstStyle/>
-          <a:p>
-            <a:pPr algn="ctr"/>
-            <a:endParaRPr lang="en-US" b="1" spc="-100" dirty="0">
-              <a:solidFill>
-                <a:schemeClr val="bg1"/>
-              </a:solidFill>
-              <a:latin typeface="Arial" panose="020B0604020202020204" pitchFamily="34" charset="0"/>
-              <a:cs typeface="Arial" panose="020B0604020202020204" pitchFamily="34" charset="0"/>
-            </a:endParaRPr>
-          </a:p>
-        </p:txBody>
-      </p:sp>
-      <p:sp>
-        <p:nvSpPr>
-          <p:cNvPr id="15" name="TextBox 14">
-            <a:extLst>
-              <a:ext uri="{FF2B5EF4-FFF2-40B4-BE49-F238E27FC236}">
-                <a16:creationId xmlns:a16="http://schemas.microsoft.com/office/drawing/2014/main" id="{E0E008A0-D52C-BF35-EF13-081021D2FB22}"/>
-              </a:ext>
-            </a:extLst>
-          </p:cNvPr>
+              <a:t>AdamW: learning rates 0.0003, 0.001 or 0.003; dropout 10-30%.</a:t>
+            </a:r>
+            <a:endParaRPr lang="en-SG" sz="1700"/>
+          </a:p>
+        </p:txBody>
+      </p:sp>
+      <p:sp>
+        <p:nvSpPr>
+          <p:cNvPr id="103" name="Project content 103"/>
           <p:cNvSpPr txBox="1"/>
           <p:nvPr/>
         </p:nvSpPr>
         <p:spPr>
-          <a:xfrm rot="5400000">
-            <a:off x="8388092" y="385128"/>
-            <a:ext cx="878767" cy="261610"/>
-          </a:xfrm>
-          <a:prstGeom prst="rect">
-            <a:avLst/>
-          </a:prstGeom>
-          <a:noFill/>
-        </p:spPr>
-        <p:txBody>
-          <a:bodyPr wrap="none" rtlCol="0">
-            <a:spAutoFit/>
-          </a:bodyPr>
-          <a:lstStyle/>
-          <a:p>
-            <a:r>
-              <a:rPr lang="en-SG" sz="1100" dirty="0">
-                <a:latin typeface="Times New Roman" panose="02020603050405020304" pitchFamily="18" charset="0"/>
-                <a:cs typeface="Times New Roman" panose="02020603050405020304" pitchFamily="18" charset="0"/>
-              </a:rPr>
-              <a:t>Introduction</a:t>
-            </a:r>
-          </a:p>
-        </p:txBody>
-      </p:sp>
-      <p:sp>
-        <p:nvSpPr>
-          <p:cNvPr id="20" name="TextBox 19">
-            <a:extLst>
-              <a:ext uri="{FF2B5EF4-FFF2-40B4-BE49-F238E27FC236}">
-                <a16:creationId xmlns:a16="http://schemas.microsoft.com/office/drawing/2014/main" id="{32039CD6-274D-8135-673B-26A04AE1C5F8}"/>
-              </a:ext>
-            </a:extLst>
-          </p:cNvPr>
-          <p:cNvSpPr txBox="1"/>
-          <p:nvPr/>
-        </p:nvSpPr>
-        <p:spPr>
-          <a:xfrm rot="5400000">
-            <a:off x="8356032" y="1274739"/>
-            <a:ext cx="942887" cy="261610"/>
-          </a:xfrm>
-          <a:prstGeom prst="rect">
-            <a:avLst/>
-          </a:prstGeom>
-          <a:noFill/>
-        </p:spPr>
-        <p:txBody>
-          <a:bodyPr wrap="none" rtlCol="0">
-            <a:spAutoFit/>
-          </a:bodyPr>
-          <a:lstStyle/>
-          <a:p>
-            <a:r>
-              <a:rPr lang="en-SG" sz="1100" dirty="0">
-                <a:latin typeface="Times New Roman" panose="02020603050405020304" pitchFamily="18" charset="0"/>
-                <a:cs typeface="Times New Roman" panose="02020603050405020304" pitchFamily="18" charset="0"/>
-              </a:rPr>
-              <a:t>Methodology</a:t>
-            </a:r>
-          </a:p>
-        </p:txBody>
-      </p:sp>
-      <p:sp>
-        <p:nvSpPr>
-          <p:cNvPr id="22" name="TextBox 21">
-            <a:extLst>
-              <a:ext uri="{FF2B5EF4-FFF2-40B4-BE49-F238E27FC236}">
-                <a16:creationId xmlns:a16="http://schemas.microsoft.com/office/drawing/2014/main" id="{EF03D6BD-FC2C-1F2D-6716-8E111EE368E8}"/>
-              </a:ext>
-            </a:extLst>
-          </p:cNvPr>
-          <p:cNvSpPr txBox="1"/>
-          <p:nvPr/>
-        </p:nvSpPr>
-        <p:spPr>
-          <a:xfrm rot="5400000">
-            <a:off x="8287102" y="2205227"/>
-            <a:ext cx="1080745" cy="261610"/>
-          </a:xfrm>
-          <a:prstGeom prst="rect">
-            <a:avLst/>
-          </a:prstGeom>
-          <a:noFill/>
-        </p:spPr>
-        <p:txBody>
-          <a:bodyPr wrap="none" rtlCol="0">
-            <a:spAutoFit/>
-          </a:bodyPr>
-          <a:lstStyle/>
-          <a:p>
-            <a:r>
-              <a:rPr lang="en-SG" sz="1100" b="1" dirty="0">
-                <a:solidFill>
-                  <a:schemeClr val="bg1"/>
-                </a:solidFill>
-                <a:latin typeface="Times New Roman" panose="02020603050405020304" pitchFamily="18" charset="0"/>
-                <a:cs typeface="Times New Roman" panose="02020603050405020304" pitchFamily="18" charset="0"/>
-              </a:rPr>
-              <a:t>AI Application</a:t>
-            </a:r>
-          </a:p>
-        </p:txBody>
-      </p:sp>
-      <p:sp>
-        <p:nvSpPr>
-          <p:cNvPr id="24" name="TextBox 23">
-            <a:extLst>
-              <a:ext uri="{FF2B5EF4-FFF2-40B4-BE49-F238E27FC236}">
-                <a16:creationId xmlns:a16="http://schemas.microsoft.com/office/drawing/2014/main" id="{EA7159A7-2980-1C5C-A36C-46E66BC9E6DD}"/>
-              </a:ext>
-            </a:extLst>
-          </p:cNvPr>
-          <p:cNvSpPr txBox="1"/>
-          <p:nvPr/>
-        </p:nvSpPr>
-        <p:spPr>
-          <a:xfrm rot="5400000">
-            <a:off x="8523546" y="2952171"/>
-            <a:ext cx="607859" cy="261610"/>
-          </a:xfrm>
-          <a:prstGeom prst="rect">
-            <a:avLst/>
-          </a:prstGeom>
-          <a:noFill/>
-        </p:spPr>
-        <p:txBody>
-          <a:bodyPr wrap="none" rtlCol="0">
-            <a:spAutoFit/>
-          </a:bodyPr>
-          <a:lstStyle/>
-          <a:p>
-            <a:r>
-              <a:rPr lang="en-SG" sz="1100" dirty="0">
-                <a:latin typeface="Times New Roman" panose="02020603050405020304" pitchFamily="18" charset="0"/>
-                <a:cs typeface="Times New Roman" panose="02020603050405020304" pitchFamily="18" charset="0"/>
-              </a:rPr>
-              <a:t>Results</a:t>
-            </a:r>
-          </a:p>
-        </p:txBody>
-      </p:sp>
-      <p:sp>
-        <p:nvSpPr>
-          <p:cNvPr id="26" name="TextBox 25">
-            <a:extLst>
-              <a:ext uri="{FF2B5EF4-FFF2-40B4-BE49-F238E27FC236}">
-                <a16:creationId xmlns:a16="http://schemas.microsoft.com/office/drawing/2014/main" id="{58FB5C2C-5C22-A92B-F77B-1189F648E37D}"/>
-              </a:ext>
-            </a:extLst>
-          </p:cNvPr>
-          <p:cNvSpPr txBox="1"/>
-          <p:nvPr/>
-        </p:nvSpPr>
-        <p:spPr>
-          <a:xfrm rot="5400000">
-            <a:off x="8428969" y="3581294"/>
-            <a:ext cx="797013" cy="261610"/>
-          </a:xfrm>
-          <a:prstGeom prst="rect">
-            <a:avLst/>
-          </a:prstGeom>
-          <a:noFill/>
-        </p:spPr>
-        <p:txBody>
-          <a:bodyPr wrap="none" rtlCol="0">
-            <a:spAutoFit/>
-          </a:bodyPr>
-          <a:lstStyle/>
-          <a:p>
-            <a:r>
-              <a:rPr lang="en-SG" sz="1100" dirty="0">
-                <a:latin typeface="Times New Roman" panose="02020603050405020304" pitchFamily="18" charset="0"/>
-                <a:cs typeface="Times New Roman" panose="02020603050405020304" pitchFamily="18" charset="0"/>
-              </a:rPr>
-              <a:t>Discussion</a:t>
-            </a:r>
-          </a:p>
-        </p:txBody>
-      </p:sp>
-      <p:sp>
-        <p:nvSpPr>
-          <p:cNvPr id="29" name="TextBox 28">
-            <a:extLst>
-              <a:ext uri="{FF2B5EF4-FFF2-40B4-BE49-F238E27FC236}">
-                <a16:creationId xmlns:a16="http://schemas.microsoft.com/office/drawing/2014/main" id="{0FBAA057-D595-210D-6A6A-87751E409B08}"/>
-              </a:ext>
-            </a:extLst>
-          </p:cNvPr>
-          <p:cNvSpPr txBox="1"/>
-          <p:nvPr/>
-        </p:nvSpPr>
-        <p:spPr>
-          <a:xfrm rot="5400000">
-            <a:off x="8416145" y="4317816"/>
-            <a:ext cx="822661" cy="261610"/>
-          </a:xfrm>
-          <a:prstGeom prst="rect">
-            <a:avLst/>
-          </a:prstGeom>
-          <a:noFill/>
-        </p:spPr>
-        <p:txBody>
-          <a:bodyPr wrap="none" rtlCol="0">
-            <a:spAutoFit/>
-          </a:bodyPr>
-          <a:lstStyle/>
-          <a:p>
-            <a:r>
-              <a:rPr lang="en-SG" sz="1100" dirty="0">
-                <a:latin typeface="Times New Roman" panose="02020603050405020304" pitchFamily="18" charset="0"/>
-                <a:cs typeface="Times New Roman" panose="02020603050405020304" pitchFamily="18" charset="0"/>
-              </a:rPr>
-              <a:t>Conclusion</a:t>
-            </a:r>
-          </a:p>
-        </p:txBody>
-      </p:sp>
-      <p:sp>
-        <p:nvSpPr>
-          <p:cNvPr id="30" name="TextBox 29">
-            <a:extLst>
-              <a:ext uri="{FF2B5EF4-FFF2-40B4-BE49-F238E27FC236}">
-                <a16:creationId xmlns:a16="http://schemas.microsoft.com/office/drawing/2014/main" id="{9948C935-4D1C-A1A4-C8BE-5AEC59739CD7}"/>
-              </a:ext>
-            </a:extLst>
-          </p:cNvPr>
-          <p:cNvSpPr txBox="1"/>
-          <p:nvPr/>
-        </p:nvSpPr>
-        <p:spPr>
           <a:xfrm>
-            <a:off x="870708" y="937730"/>
-            <a:ext cx="6500000" cy="369332"/>
-          </a:xfrm>
-          <a:prstGeom prst="rect">
-            <a:avLst/>
-          </a:prstGeom>
-          <a:noFill/>
-        </p:spPr>
-        <p:txBody>
-          <a:bodyPr wrap="none" rtlCol="0">
-            <a:spAutoFit/>
-          </a:bodyPr>
-          <a:lstStyle/>
-          <a:p>
-            <a:r>
-              <a:rPr lang="en-SG" b="1" dirty="0">
-                <a:latin typeface="Times New Roman" panose="02020603050405020304" pitchFamily="18" charset="0"/>
-                <a:cs typeface="Times New Roman" panose="02020603050405020304" pitchFamily="18" charset="0"/>
-              </a:rPr>
-              <a:t>Training and validation</a:t>
-            </a:r>
-          </a:p>
-        </p:txBody>
-      </p:sp>
-      <p:graphicFrame>
-        <p:nvGraphicFramePr>
-          <p:cNvPr id="101" name="Editable project table 101"/>
-          <p:cNvGraphicFramePr/>
-          <p:nvPr/>
-        </p:nvGraphicFramePr>
-        <p:xfrm>
-          <a:off x="594360" y="1463040"/>
-          <a:ext cx="7406640" cy="2926080"/>
-        </p:xfrm>
-        <a:graphic>
-          <a:graphicData uri="http://schemas.openxmlformats.org/drawingml/2006/table">
-            <a:tbl>
-              <a:tblPr firstRow="1" bandRow="0"/>
-              <a:tblGrid>
-                <a:gridCol w="2148840"/>
-                <a:gridCol w="5257800"/>
-              </a:tblGrid>
-              <a:tr h="365760">
-                <a:tc>
-                  <a:txBody>
-                    <a:bodyPr wrap="square"/>
-                    <a:lstStyle/>
-                    <a:p>
-                      <a:pPr algn="l">
-                        <a:lnSpc>
-                          <a:spcPct val="105000"/>
-                        </a:lnSpc>
-                        <a:spcAft>
-                          <a:spcPts val="0"/>
-                        </a:spcAft>
-                        <a:buNone/>
-                      </a:pPr>
-                      <a:r>
-                        <a:rPr lang="en-SG" sz="1700" b="1">
-                          <a:solidFill>
-                            <a:srgbClr val="FFFFFF"/>
-                          </a:solidFill>
-                          <a:latin typeface="Times New Roman"/>
-                          <a:ea typeface="Times New Roman"/>
-                          <a:cs typeface="Times New Roman"/>
-                        </a:rPr>
-                        <a:t>Search component</a:t>
-                      </a:r>
-                      <a:endParaRPr lang="en-SG" sz="1700"/>
-                    </a:p>
-                  </a:txBody>
-                  <a:tcPr marL="91440" marR="91440" marT="45720" marB="45720" anchor="ctr">
-                    <a:lnL w="0">
-                      <a:noFill/>
-                    </a:lnL>
-                    <a:lnR w="0">
-                      <a:noFill/>
-                    </a:lnR>
-                    <a:lnT w="0">
-                      <a:noFill/>
-                    </a:lnT>
-                    <a:lnB w="6350">
-                      <a:solidFill>
-                        <a:srgbClr val="CCD5E0"/>
-                      </a:solidFill>
-                    </a:lnB>
-                    <a:solidFill>
-                      <a:srgbClr val="181C62"/>
-                    </a:solidFill>
-                  </a:tcPr>
-                </a:tc>
-                <a:tc>
-                  <a:txBody>
-                    <a:bodyPr wrap="square"/>
-                    <a:lstStyle/>
-                    <a:p>
-                      <a:pPr algn="l">
-                        <a:lnSpc>
-                          <a:spcPct val="105000"/>
-                        </a:lnSpc>
-                        <a:spcAft>
-                          <a:spcPts val="0"/>
-                        </a:spcAft>
-                        <a:buNone/>
-                      </a:pPr>
-                      <a:r>
-                        <a:rPr lang="en-SG" sz="1700" b="1">
-                          <a:solidFill>
-                            <a:srgbClr val="FFFFFF"/>
-                          </a:solidFill>
-                          <a:latin typeface="Times New Roman"/>
-                          <a:ea typeface="Times New Roman"/>
-                          <a:cs typeface="Times New Roman"/>
-                        </a:rPr>
-                        <a:t>Settings</a:t>
-                      </a:r>
-                      <a:endParaRPr lang="en-SG" sz="1700"/>
-                    </a:p>
-                  </a:txBody>
-                  <a:tcPr marL="91440" marR="91440" marT="45720" marB="45720" anchor="ctr">
-                    <a:lnL w="0">
-                      <a:noFill/>
-                    </a:lnL>
-                    <a:lnR w="0">
-                      <a:noFill/>
-                    </a:lnR>
-                    <a:lnT w="0">
-                      <a:noFill/>
-                    </a:lnT>
-                    <a:lnB w="6350">
-                      <a:solidFill>
-                        <a:srgbClr val="CCD5E0"/>
-                      </a:solidFill>
-                    </a:lnB>
-                    <a:solidFill>
-                      <a:srgbClr val="181C62"/>
-                    </a:solidFill>
-                  </a:tcPr>
-                </a:tc>
-              </a:tr>
-              <a:tr h="640080">
-                <a:tc>
-                  <a:txBody>
-                    <a:bodyPr wrap="square"/>
-                    <a:lstStyle/>
-                    <a:p>
-                      <a:pPr algn="l">
-                        <a:lnSpc>
-                          <a:spcPct val="105000"/>
-                        </a:lnSpc>
-                        <a:spcAft>
-                          <a:spcPts val="0"/>
-                        </a:spcAft>
-                        <a:buNone/>
-                      </a:pPr>
-                      <a:r>
-                        <a:rPr lang="en-SG" sz="1700" b="0">
-                          <a:solidFill>
-                            <a:srgbClr val="000000"/>
-                          </a:solidFill>
-                          <a:latin typeface="Times New Roman"/>
-                          <a:ea typeface="Times New Roman"/>
-                          <a:cs typeface="Times New Roman"/>
-                        </a:rPr>
-                        <a:t>Configurations</a:t>
-                      </a:r>
-                      <a:endParaRPr lang="en-SG" sz="1700"/>
-                    </a:p>
-                  </a:txBody>
-                  <a:tcPr marL="91440" marR="91440" marT="45720" marB="45720" anchor="ctr">
-                    <a:lnL w="0">
-                      <a:noFill/>
-                    </a:lnL>
-                    <a:lnR w="0">
-                      <a:noFill/>
-                    </a:lnR>
-                    <a:lnT w="0">
-                      <a:noFill/>
-                    </a:lnT>
-                    <a:lnB w="6350">
-                      <a:solidFill>
-                        <a:srgbClr val="CCD5E0"/>
-                      </a:solidFill>
-                    </a:lnB>
-                    <a:solidFill>
-                      <a:srgbClr val="FFFFFF"/>
-                    </a:solidFill>
-                  </a:tcPr>
-                </a:tc>
-                <a:tc>
-                  <a:txBody>
-                    <a:bodyPr wrap="square"/>
-                    <a:lstStyle/>
-                    <a:p>
-                      <a:pPr algn="l">
-                        <a:lnSpc>
-                          <a:spcPct val="105000"/>
-                        </a:lnSpc>
-                        <a:spcAft>
-                          <a:spcPts val="0"/>
-                        </a:spcAft>
-                        <a:buNone/>
-                      </a:pPr>
-                      <a:r>
-                        <a:rPr lang="en-SG" sz="1700" b="0">
-                          <a:solidFill>
-                            <a:srgbClr val="000000"/>
-                          </a:solidFill>
-                          <a:latin typeface="Times New Roman"/>
-                          <a:ea typeface="Times New Roman"/>
-                          <a:cs typeface="Times New Roman"/>
-                        </a:rPr>
-                        <a:t>18 configurations across 5 folds (90 trials)</a:t>
-                      </a:r>
-                      <a:endParaRPr lang="en-SG" sz="1700"/>
-                    </a:p>
-                    <a:p>
-                      <a:pPr algn="l">
-                        <a:lnSpc>
-                          <a:spcPct val="105000"/>
-                        </a:lnSpc>
-                        <a:spcAft>
-                          <a:spcPts val="0"/>
-                        </a:spcAft>
-                        <a:buNone/>
-                      </a:pPr>
-                      <a:r>
-                        <a:rPr lang="en-SG" sz="1700" b="0">
-                          <a:solidFill>
-                            <a:srgbClr val="000000"/>
-                          </a:solidFill>
-                          <a:latin typeface="Times New Roman"/>
-                          <a:ea typeface="Times New Roman"/>
-                          <a:cs typeface="Times New Roman"/>
-                        </a:rPr>
-                        <a:t>AdamW optimiser, batches of 256 or 512</a:t>
-                      </a:r>
-                      <a:endParaRPr lang="en-SG" sz="1700"/>
-                    </a:p>
-                  </a:txBody>
-                  <a:tcPr marL="91440" marR="91440" marT="45720" marB="45720" anchor="ctr">
-                    <a:lnL w="0">
-                      <a:noFill/>
-                    </a:lnL>
-                    <a:lnR w="0">
-                      <a:noFill/>
-                    </a:lnR>
-                    <a:lnT w="0">
-                      <a:noFill/>
-                    </a:lnT>
-                    <a:lnB w="6350">
-                      <a:solidFill>
-                        <a:srgbClr val="CCD5E0"/>
-                      </a:solidFill>
-                    </a:lnB>
-                    <a:solidFill>
-                      <a:srgbClr val="FFFFFF"/>
-                    </a:solidFill>
-                  </a:tcPr>
-                </a:tc>
-              </a:tr>
-              <a:tr h="640080">
-                <a:tc>
-                  <a:txBody>
-                    <a:bodyPr wrap="square"/>
-                    <a:lstStyle/>
-                    <a:p>
-                      <a:pPr algn="l">
-                        <a:lnSpc>
-                          <a:spcPct val="105000"/>
-                        </a:lnSpc>
-                        <a:spcAft>
-                          <a:spcPts val="0"/>
-                        </a:spcAft>
-                        <a:buNone/>
-                      </a:pPr>
-                      <a:r>
-                        <a:rPr lang="en-SG" sz="1700" b="0">
-                          <a:solidFill>
-                            <a:srgbClr val="000000"/>
-                          </a:solidFill>
-                          <a:latin typeface="Times New Roman"/>
-                          <a:ea typeface="Times New Roman"/>
-                          <a:cs typeface="Times New Roman"/>
-                        </a:rPr>
-                        <a:t>Learning rates</a:t>
-                      </a:r>
-                      <a:endParaRPr lang="en-SG" sz="1700"/>
-                    </a:p>
-                  </a:txBody>
-                  <a:tcPr marL="91440" marR="91440" marT="45720" marB="45720" anchor="ctr">
-                    <a:lnL w="0">
-                      <a:noFill/>
-                    </a:lnL>
-                    <a:lnR w="0">
-                      <a:noFill/>
-                    </a:lnR>
-                    <a:lnT w="0">
-                      <a:noFill/>
-                    </a:lnT>
-                    <a:lnB w="6350">
-                      <a:solidFill>
-                        <a:srgbClr val="CCD5E0"/>
-                      </a:solidFill>
-                    </a:lnB>
-                    <a:solidFill>
-                      <a:srgbClr val="FFFFFF"/>
-                    </a:solidFill>
-                  </a:tcPr>
-                </a:tc>
-                <a:tc>
-                  <a:txBody>
-                    <a:bodyPr wrap="square"/>
-                    <a:lstStyle/>
-                    <a:p>
-                      <a:pPr algn="l">
-                        <a:lnSpc>
-                          <a:spcPct val="105000"/>
-                        </a:lnSpc>
-                        <a:spcAft>
-                          <a:spcPts val="0"/>
-                        </a:spcAft>
-                        <a:buNone/>
-                      </a:pPr>
-                      <a:r>
-                        <a:rPr lang="en-SG" sz="1700" b="0">
-                          <a:solidFill>
-                            <a:srgbClr val="000000"/>
-                          </a:solidFill>
-                          <a:latin typeface="Times New Roman"/>
-                          <a:ea typeface="Times New Roman"/>
-                          <a:cs typeface="Times New Roman"/>
-                        </a:rPr>
-                        <a:t>0.0003, 0.001 and 0.003</a:t>
-                      </a:r>
-                      <a:endParaRPr lang="en-SG" sz="1700"/>
-                    </a:p>
-                    <a:p>
-                      <a:pPr algn="l">
-                        <a:lnSpc>
-                          <a:spcPct val="105000"/>
-                        </a:lnSpc>
-                        <a:spcAft>
-                          <a:spcPts val="0"/>
-                        </a:spcAft>
-                        <a:buNone/>
-                      </a:pPr>
-                      <a:r>
-                        <a:rPr lang="en-SG" sz="1700" b="0">
-                          <a:solidFill>
-                            <a:srgbClr val="000000"/>
-                          </a:solidFill>
-                          <a:latin typeface="Times New Roman"/>
-                          <a:ea typeface="Times New Roman"/>
-                          <a:cs typeface="Times New Roman"/>
-                        </a:rPr>
-                        <a:t>Constant, plateau reduction or cosine decay</a:t>
-                      </a:r>
-                      <a:endParaRPr lang="en-SG" sz="1700"/>
-                    </a:p>
-                  </a:txBody>
-                  <a:tcPr marL="91440" marR="91440" marT="45720" marB="45720" anchor="ctr">
-                    <a:lnL w="0">
-                      <a:noFill/>
-                    </a:lnL>
-                    <a:lnR w="0">
-                      <a:noFill/>
-                    </a:lnR>
-                    <a:lnT w="0">
-                      <a:noFill/>
-                    </a:lnT>
-                    <a:lnB w="6350">
-                      <a:solidFill>
-                        <a:srgbClr val="CCD5E0"/>
-                      </a:solidFill>
-                    </a:lnB>
-                    <a:solidFill>
-                      <a:srgbClr val="FFFFFF"/>
-                    </a:solidFill>
-                  </a:tcPr>
-                </a:tc>
-              </a:tr>
-              <a:tr h="640080">
-                <a:tc>
-                  <a:txBody>
-                    <a:bodyPr wrap="square"/>
-                    <a:lstStyle/>
-                    <a:p>
-                      <a:pPr algn="l">
-                        <a:lnSpc>
-                          <a:spcPct val="105000"/>
-                        </a:lnSpc>
-                        <a:spcAft>
-                          <a:spcPts val="0"/>
-                        </a:spcAft>
-                        <a:buNone/>
-                      </a:pPr>
-                      <a:r>
-                        <a:rPr lang="en-SG" sz="1700" b="0">
-                          <a:solidFill>
-                            <a:srgbClr val="000000"/>
-                          </a:solidFill>
-                          <a:latin typeface="Times New Roman"/>
-                          <a:ea typeface="Times New Roman"/>
-                          <a:cs typeface="Times New Roman"/>
-                        </a:rPr>
-                        <a:t>Regularisation</a:t>
-                      </a:r>
-                      <a:endParaRPr lang="en-SG" sz="1700"/>
-                    </a:p>
-                  </a:txBody>
-                  <a:tcPr marL="91440" marR="91440" marT="45720" marB="45720" anchor="ctr">
-                    <a:lnL w="0">
-                      <a:noFill/>
-                    </a:lnL>
-                    <a:lnR w="0">
-                      <a:noFill/>
-                    </a:lnR>
-                    <a:lnT w="0">
-                      <a:noFill/>
-                    </a:lnT>
-                    <a:lnB w="6350">
-                      <a:solidFill>
-                        <a:srgbClr val="CCD5E0"/>
-                      </a:solidFill>
-                    </a:lnB>
-                    <a:solidFill>
-                      <a:srgbClr val="FFFFFF"/>
-                    </a:solidFill>
-                  </a:tcPr>
-                </a:tc>
-                <a:tc>
-                  <a:txBody>
-                    <a:bodyPr wrap="square"/>
-                    <a:lstStyle/>
-                    <a:p>
-                      <a:pPr algn="l">
-                        <a:lnSpc>
-                          <a:spcPct val="105000"/>
-                        </a:lnSpc>
-                        <a:spcAft>
-                          <a:spcPts val="0"/>
-                        </a:spcAft>
-                        <a:buNone/>
-                      </a:pPr>
-                      <a:r>
-                        <a:rPr lang="en-SG" sz="1700" b="0">
-                          <a:solidFill>
-                            <a:srgbClr val="000000"/>
-                          </a:solidFill>
-                          <a:latin typeface="Times New Roman"/>
-                          <a:ea typeface="Times New Roman"/>
-                          <a:cs typeface="Times New Roman"/>
-                        </a:rPr>
-                        <a:t>Dropout 10–30%, weight decay 0.001–0.1</a:t>
-                      </a:r>
-                      <a:endParaRPr lang="en-SG" sz="1700"/>
-                    </a:p>
-                    <a:p>
-                      <a:pPr algn="l">
-                        <a:lnSpc>
-                          <a:spcPct val="105000"/>
-                        </a:lnSpc>
-                        <a:spcAft>
-                          <a:spcPts val="0"/>
-                        </a:spcAft>
-                        <a:buNone/>
-                      </a:pPr>
-                      <a:r>
-                        <a:rPr lang="en-SG" sz="1700" b="0">
-                          <a:solidFill>
-                            <a:srgbClr val="000000"/>
-                          </a:solidFill>
-                          <a:latin typeface="Times New Roman"/>
-                          <a:ea typeface="Times New Roman"/>
-                          <a:cs typeface="Times New Roman"/>
-                        </a:rPr>
-                        <a:t>Binary or TF-IDF input encoding</a:t>
-                      </a:r>
-                      <a:endParaRPr lang="en-SG" sz="1700"/>
-                    </a:p>
-                  </a:txBody>
-                  <a:tcPr marL="91440" marR="91440" marT="45720" marB="45720" anchor="ctr">
-                    <a:lnL w="0">
-                      <a:noFill/>
-                    </a:lnL>
-                    <a:lnR w="0">
-                      <a:noFill/>
-                    </a:lnR>
-                    <a:lnT w="0">
-                      <a:noFill/>
-                    </a:lnT>
-                    <a:lnB w="6350">
-                      <a:solidFill>
-                        <a:srgbClr val="CCD5E0"/>
-                      </a:solidFill>
-                    </a:lnB>
-                    <a:solidFill>
-                      <a:srgbClr val="FFFFFF"/>
-                    </a:solidFill>
-                  </a:tcPr>
-                </a:tc>
-              </a:tr>
-              <a:tr h="640080">
-                <a:tc>
-                  <a:txBody>
-                    <a:bodyPr wrap="square"/>
-                    <a:lstStyle/>
-                    <a:p>
-                      <a:pPr algn="l">
-                        <a:lnSpc>
-                          <a:spcPct val="105000"/>
-                        </a:lnSpc>
-                        <a:spcAft>
-                          <a:spcPts val="0"/>
-                        </a:spcAft>
-                        <a:buNone/>
-                      </a:pPr>
-                      <a:r>
-                        <a:rPr lang="en-SG" sz="1700" b="0">
-                          <a:solidFill>
-                            <a:srgbClr val="000000"/>
-                          </a:solidFill>
-                          <a:latin typeface="Times New Roman"/>
-                          <a:ea typeface="Times New Roman"/>
-                          <a:cs typeface="Times New Roman"/>
-                        </a:rPr>
-                        <a:t>Validation per fold</a:t>
-                      </a:r>
-                      <a:endParaRPr lang="en-SG" sz="1700"/>
-                    </a:p>
-                  </a:txBody>
-                  <a:tcPr marL="91440" marR="91440" marT="45720" marB="45720" anchor="ctr">
-                    <a:lnL w="0">
-                      <a:noFill/>
-                    </a:lnL>
-                    <a:lnR w="0">
-                      <a:noFill/>
-                    </a:lnR>
-                    <a:lnT w="0">
-                      <a:noFill/>
-                    </a:lnT>
-                    <a:lnB w="6350">
-                      <a:solidFill>
-                        <a:srgbClr val="CCD5E0"/>
-                      </a:solidFill>
-                    </a:lnB>
-                    <a:solidFill>
-                      <a:srgbClr val="FFFFFF"/>
-                    </a:solidFill>
-                  </a:tcPr>
-                </a:tc>
-                <a:tc>
-                  <a:txBody>
-                    <a:bodyPr wrap="square"/>
-                    <a:lstStyle/>
-                    <a:p>
-                      <a:pPr algn="l">
-                        <a:lnSpc>
-                          <a:spcPct val="105000"/>
-                        </a:lnSpc>
-                        <a:spcAft>
-                          <a:spcPts val="0"/>
-                        </a:spcAft>
-                        <a:buNone/>
-                      </a:pPr>
-                      <a:r>
-                        <a:rPr lang="en-SG" sz="1700" b="0">
-                          <a:solidFill>
-                            <a:srgbClr val="000000"/>
-                          </a:solidFill>
-                          <a:latin typeface="Times New Roman"/>
-                          <a:ea typeface="Times New Roman"/>
-                          <a:cs typeface="Times New Roman"/>
-                        </a:rPr>
-                        <a:t>9,600 training and 2,400 validation profiles</a:t>
-                      </a:r>
-                      <a:endParaRPr lang="en-SG" sz="1700"/>
-                    </a:p>
-                    <a:p>
-                      <a:pPr algn="l">
-                        <a:lnSpc>
-                          <a:spcPct val="105000"/>
-                        </a:lnSpc>
-                        <a:spcAft>
-                          <a:spcPts val="0"/>
-                        </a:spcAft>
-                        <a:buNone/>
-                      </a:pPr>
-                      <a:r>
-                        <a:rPr lang="en-SG" sz="1700" b="0">
-                          <a:solidFill>
-                            <a:srgbClr val="000000"/>
-                          </a:solidFill>
-                          <a:latin typeface="Times New Roman"/>
-                          <a:ea typeface="Times New Roman"/>
-                          <a:cs typeface="Times New Roman"/>
-                        </a:rPr>
-                        <a:t>3,000 separate test profiles</a:t>
-                      </a:r>
-                      <a:endParaRPr lang="en-SG" sz="1700"/>
-                    </a:p>
-                  </a:txBody>
-                  <a:tcPr marL="91440" marR="91440" marT="45720" marB="45720" anchor="ctr">
-                    <a:lnL w="0">
-                      <a:noFill/>
-                    </a:lnL>
-                    <a:lnR w="0">
-                      <a:noFill/>
-                    </a:lnR>
-                    <a:lnT w="0">
-                      <a:noFill/>
-                    </a:lnT>
-                    <a:lnB w="6350">
-                      <a:solidFill>
-                        <a:srgbClr val="CCD5E0"/>
-                      </a:solidFill>
-                    </a:lnB>
-                    <a:solidFill>
-                      <a:srgbClr val="FFFFFF"/>
-                    </a:solidFill>
-                  </a:tcPr>
-                </a:tc>
-              </a:tr>
-            </a:tbl>
-          </a:graphicData>
-        </a:graphic>
-      </p:graphicFrame>
-      <p:sp>
-        <p:nvSpPr>
-          <p:cNvPr id="102" name="Project content 102"/>
-          <p:cNvSpPr txBox="1"/>
-          <p:nvPr/>
-        </p:nvSpPr>
-        <p:spPr>
-          <a:xfrm>
-            <a:off x="594360" y="4553712"/>
-            <a:ext cx="7406640" cy="310896"/>
+            <a:off x="594360" y="4224528"/>
+            <a:ext cx="7406640" cy="292608"/>
           </a:xfrm>
           <a:prstGeom prst="rect">
             <a:avLst/>
@@ -9510,7 +9383,56 @@
               <a:buNone/>
             </a:pPr>
             <a:r>
-              <a:rPr lang="en-SG" sz="1600" b="1">
+              <a:rPr lang="en-SG" sz="1700" b="0">
+                <a:solidFill>
+                  <a:srgbClr val="000000"/>
+                </a:solidFill>
+                <a:latin typeface="Times New Roman"/>
+                <a:ea typeface="Times New Roman"/>
+                <a:cs typeface="Times New Roman"/>
+              </a:rPr>
+              <a:t>Inner split: 9,600 train / 2,400 validate; 3,000 test profiles held out.</a:t>
+            </a:r>
+            <a:endParaRPr lang="en-SG" sz="1700"/>
+          </a:p>
+        </p:txBody>
+      </p:sp>
+      <p:sp>
+        <p:nvSpPr>
+          <p:cNvPr id="104" name="Project content 104"/>
+          <p:cNvSpPr txBox="1"/>
+          <p:nvPr/>
+        </p:nvSpPr>
+        <p:spPr>
+          <a:xfrm>
+            <a:off x="594360" y="4581144"/>
+            <a:ext cx="7406640" cy="274320"/>
+          </a:xfrm>
+          <a:prstGeom prst="rect">
+            <a:avLst/>
+          </a:prstGeom>
+          <a:noFill/>
+          <a:ln>
+            <a:noFill/>
+          </a:ln>
+        </p:spPr>
+        <p:txBody>
+          <a:bodyPr wrap="square" lIns="0" rIns="0" tIns="0" bIns="0" anchor="t">
+            <a:noAutofit/>
+          </a:bodyPr>
+          <a:lstStyle/>
+          <a:p>
+            <a:pPr algn="l">
+              <a:lnSpc>
+                <a:spcPct val="105000"/>
+              </a:lnSpc>
+              <a:spcAft>
+                <a:spcPts val="0"/>
+              </a:spcAft>
+              <a:buNone/>
+            </a:pPr>
+            <a:r>
+              <a:rPr lang="en-SG" sz="1650" b="1">
                 <a:solidFill>
                   <a:srgbClr val="181C62"/>
                 </a:solidFill>
@@ -9518,9 +9440,9 @@
                 <a:ea typeface="Times New Roman"/>
                 <a:cs typeface="Times New Roman"/>
               </a:rPr>
-              <a:t>Early stopping: patience 12, limit 60 epochs. Trials ran for 13–46 epochs.</a:t>
-            </a:r>
-            <a:endParaRPr lang="en-SG" sz="1600"/>
+              <a:t>22 career outputs; network settings are selected within each fold.</a:t>
+            </a:r>
+            <a:endParaRPr lang="en-SG" sz="1650"/>
           </a:p>
         </p:txBody>
       </p:sp>

</xml_diff>